<commit_message>
Added params in front matter and sharing reports slide
</commit_message>
<xml_diff>
--- a/WIP/Presentation?_Intro_Quarto.pptx
+++ b/WIP/Presentation?_Intro_Quarto.pptx
@@ -5,10 +5,10 @@
     <p:sldMasterId id="2147483648" r:id="rId4"/>
   </p:sldMasterIdLst>
   <p:notesMasterIdLst>
-    <p:notesMasterId r:id="rId27"/>
+    <p:notesMasterId r:id="rId29"/>
   </p:notesMasterIdLst>
   <p:handoutMasterIdLst>
-    <p:handoutMasterId r:id="rId28"/>
+    <p:handoutMasterId r:id="rId30"/>
   </p:handoutMasterIdLst>
   <p:sldIdLst>
     <p:sldId id="1833" r:id="rId5"/>
@@ -28,11 +28,13 @@
     <p:sldId id="2147377455" r:id="rId19"/>
     <p:sldId id="2147377453" r:id="rId20"/>
     <p:sldId id="2147377454" r:id="rId21"/>
-    <p:sldId id="2147377456" r:id="rId22"/>
-    <p:sldId id="2147377457" r:id="rId23"/>
-    <p:sldId id="2147377461" r:id="rId24"/>
-    <p:sldId id="2147377433" r:id="rId25"/>
-    <p:sldId id="1831" r:id="rId26"/>
+    <p:sldId id="2147377462" r:id="rId22"/>
+    <p:sldId id="2147377456" r:id="rId23"/>
+    <p:sldId id="2147377457" r:id="rId24"/>
+    <p:sldId id="2147377461" r:id="rId25"/>
+    <p:sldId id="2147377463" r:id="rId26"/>
+    <p:sldId id="2147377433" r:id="rId27"/>
+    <p:sldId id="1831" r:id="rId28"/>
   </p:sldIdLst>
   <p:sldSz cx="12192000" cy="6858000"/>
   <p:notesSz cx="6858000" cy="9144000"/>
@@ -256,7 +258,7 @@
           <a:p>
             <a:fld id="{AA487248-395E-43C7-BF4F-D00C5F5B2E35}" type="datetimeFigureOut">
               <a:rPr lang="en-US" smtClean="0"/>
-              <a:t>2/25/26</a:t>
+              <a:t>3/6/26</a:t>
             </a:fld>
             <a:endParaRPr lang="en-US" dirty="0"/>
           </a:p>
@@ -433,7 +435,7 @@
           <a:p>
             <a:fld id="{6FD7AD6A-ED84-4F8E-A912-F7C11544A729}" type="datetimeFigureOut">
               <a:rPr lang="en-US" smtClean="0"/>
-              <a:t>2/25/26</a:t>
+              <a:t>3/6/26</a:t>
             </a:fld>
             <a:endParaRPr lang="en-US" dirty="0"/>
           </a:p>
@@ -1441,6 +1443,114 @@
         <p:cNvPr id="1" name="">
           <a:extLst>
             <a:ext uri="{FF2B5EF4-FFF2-40B4-BE49-F238E27FC236}">
+              <a16:creationId xmlns:a16="http://schemas.microsoft.com/office/drawing/2014/main" id="{EBEEAA82-8D32-7EFD-8869-CE58CCF12090}"/>
+            </a:ext>
+          </a:extLst>
+        </p:cNvPr>
+        <p:cNvGrpSpPr/>
+        <p:nvPr/>
+      </p:nvGrpSpPr>
+      <p:grpSpPr>
+        <a:xfrm>
+          <a:off x="0" y="0"/>
+          <a:ext cx="0" cy="0"/>
+          <a:chOff x="0" y="0"/>
+          <a:chExt cx="0" cy="0"/>
+        </a:xfrm>
+      </p:grpSpPr>
+      <p:sp>
+        <p:nvSpPr>
+          <p:cNvPr id="2" name="Slide Image Placeholder 1">
+            <a:extLst>
+              <a:ext uri="{FF2B5EF4-FFF2-40B4-BE49-F238E27FC236}">
+                <a16:creationId xmlns:a16="http://schemas.microsoft.com/office/drawing/2014/main" id="{82CCDAE7-0606-2429-BBDE-85893A78BFF1}"/>
+              </a:ext>
+            </a:extLst>
+          </p:cNvPr>
+          <p:cNvSpPr>
+            <a:spLocks noGrp="1" noRot="1" noChangeAspect="1"/>
+          </p:cNvSpPr>
+          <p:nvPr>
+            <p:ph type="sldImg"/>
+          </p:nvPr>
+        </p:nvSpPr>
+        <p:spPr/>
+      </p:sp>
+      <p:sp>
+        <p:nvSpPr>
+          <p:cNvPr id="3" name="Notes Placeholder 2">
+            <a:extLst>
+              <a:ext uri="{FF2B5EF4-FFF2-40B4-BE49-F238E27FC236}">
+                <a16:creationId xmlns:a16="http://schemas.microsoft.com/office/drawing/2014/main" id="{F0C4615E-0023-1F3D-650C-84A95DFCCB68}"/>
+              </a:ext>
+            </a:extLst>
+          </p:cNvPr>
+          <p:cNvSpPr>
+            <a:spLocks noGrp="1"/>
+          </p:cNvSpPr>
+          <p:nvPr>
+            <p:ph type="body" idx="1"/>
+          </p:nvPr>
+        </p:nvSpPr>
+        <p:spPr/>
+        <p:txBody>
+          <a:bodyPr/>
+          <a:lstStyle/>
+          <a:p>
+            <a:endParaRPr lang="en-US" dirty="0"/>
+          </a:p>
+        </p:txBody>
+      </p:sp>
+      <p:sp>
+        <p:nvSpPr>
+          <p:cNvPr id="4" name="Slide Number Placeholder 3">
+            <a:extLst>
+              <a:ext uri="{FF2B5EF4-FFF2-40B4-BE49-F238E27FC236}">
+                <a16:creationId xmlns:a16="http://schemas.microsoft.com/office/drawing/2014/main" id="{F375C096-2E4E-5922-B63C-2DA79D110B95}"/>
+              </a:ext>
+            </a:extLst>
+          </p:cNvPr>
+          <p:cNvSpPr>
+            <a:spLocks noGrp="1"/>
+          </p:cNvSpPr>
+          <p:nvPr>
+            <p:ph type="sldNum" sz="quarter" idx="5"/>
+          </p:nvPr>
+        </p:nvSpPr>
+        <p:spPr/>
+        <p:txBody>
+          <a:bodyPr/>
+          <a:lstStyle/>
+          <a:p>
+            <a:fld id="{6EC30964-BF55-46F8-B0CF-231697E08BCE}" type="slidenum">
+              <a:rPr lang="en-US" smtClean="0"/>
+              <a:t>18</a:t>
+            </a:fld>
+            <a:endParaRPr lang="en-US" dirty="0"/>
+          </a:p>
+        </p:txBody>
+      </p:sp>
+    </p:spTree>
+    <p:extLst>
+      <p:ext uri="{BB962C8B-B14F-4D97-AF65-F5344CB8AC3E}">
+        <p14:creationId xmlns:p14="http://schemas.microsoft.com/office/powerpoint/2010/main" val="2297276426"/>
+      </p:ext>
+    </p:extLst>
+  </p:cSld>
+  <p:clrMapOvr>
+    <a:masterClrMapping/>
+  </p:clrMapOvr>
+</p:notes>
+</file>
+
+<file path=ppt/notesSlides/notesSlide17.xml><?xml version="1.0" encoding="utf-8"?>
+<p:notes xmlns:a="http://schemas.openxmlformats.org/drawingml/2006/main" xmlns:r="http://schemas.openxmlformats.org/officeDocument/2006/relationships" xmlns:p="http://schemas.openxmlformats.org/presentationml/2006/main">
+  <p:cSld>
+    <p:spTree>
+      <p:nvGrpSpPr>
+        <p:cNvPr id="1" name="">
+          <a:extLst>
+            <a:ext uri="{FF2B5EF4-FFF2-40B4-BE49-F238E27FC236}">
               <a16:creationId xmlns:a16="http://schemas.microsoft.com/office/drawing/2014/main" id="{8DECA814-045E-7342-56D2-8EA0E6B75079}"/>
             </a:ext>
           </a:extLst>
@@ -1522,7 +1632,7 @@
           <a:p>
             <a:fld id="{6EC30964-BF55-46F8-B0CF-231697E08BCE}" type="slidenum">
               <a:rPr lang="en-US" smtClean="0"/>
-              <a:t>19</a:t>
+              <a:t>20</a:t>
             </a:fld>
             <a:endParaRPr lang="en-US" dirty="0"/>
           </a:p>
@@ -1541,7 +1651,7 @@
 </p:notes>
 </file>
 
-<file path=ppt/notesSlides/notesSlide17.xml><?xml version="1.0" encoding="utf-8"?>
+<file path=ppt/notesSlides/notesSlide18.xml><?xml version="1.0" encoding="utf-8"?>
 <p:notes xmlns:a="http://schemas.openxmlformats.org/drawingml/2006/main" xmlns:r="http://schemas.openxmlformats.org/officeDocument/2006/relationships" xmlns:p="http://schemas.openxmlformats.org/presentationml/2006/main">
   <p:cSld>
     <p:spTree>
@@ -1630,7 +1740,7 @@
           <a:p>
             <a:fld id="{6EC30964-BF55-46F8-B0CF-231697E08BCE}" type="slidenum">
               <a:rPr lang="en-US" smtClean="0"/>
-              <a:t>20</a:t>
+              <a:t>21</a:t>
             </a:fld>
             <a:endParaRPr lang="en-US" dirty="0"/>
           </a:p>
@@ -1649,12 +1759,18 @@
 </p:notes>
 </file>
 
-<file path=ppt/notesSlides/notesSlide18.xml><?xml version="1.0" encoding="utf-8"?>
+<file path=ppt/notesSlides/notesSlide19.xml><?xml version="1.0" encoding="utf-8"?>
 <p:notes xmlns:a="http://schemas.openxmlformats.org/drawingml/2006/main" xmlns:r="http://schemas.openxmlformats.org/officeDocument/2006/relationships" xmlns:p="http://schemas.openxmlformats.org/presentationml/2006/main">
   <p:cSld>
     <p:spTree>
       <p:nvGrpSpPr>
-        <p:cNvPr id="1" name=""/>
+        <p:cNvPr id="1" name="">
+          <a:extLst>
+            <a:ext uri="{FF2B5EF4-FFF2-40B4-BE49-F238E27FC236}">
+              <a16:creationId xmlns:a16="http://schemas.microsoft.com/office/drawing/2014/main" id="{C1E15AE1-C9B4-51D8-BFE3-7896219E71AD}"/>
+            </a:ext>
+          </a:extLst>
+        </p:cNvPr>
         <p:cNvGrpSpPr/>
         <p:nvPr/>
       </p:nvGrpSpPr>
@@ -1668,7 +1784,13 @@
       </p:grpSpPr>
       <p:sp>
         <p:nvSpPr>
-          <p:cNvPr id="2" name="Slide Image Placeholder 1"/>
+          <p:cNvPr id="2" name="Slide Image Placeholder 1">
+            <a:extLst>
+              <a:ext uri="{FF2B5EF4-FFF2-40B4-BE49-F238E27FC236}">
+                <a16:creationId xmlns:a16="http://schemas.microsoft.com/office/drawing/2014/main" id="{90DD222F-2EF9-4D78-F7E5-620F6FBC63D6}"/>
+              </a:ext>
+            </a:extLst>
+          </p:cNvPr>
           <p:cNvSpPr>
             <a:spLocks noGrp="1" noRot="1" noChangeAspect="1"/>
           </p:cNvSpPr>
@@ -1680,7 +1802,13 @@
       </p:sp>
       <p:sp>
         <p:nvSpPr>
-          <p:cNvPr id="3" name="Notes Placeholder 2"/>
+          <p:cNvPr id="3" name="Notes Placeholder 2">
+            <a:extLst>
+              <a:ext uri="{FF2B5EF4-FFF2-40B4-BE49-F238E27FC236}">
+                <a16:creationId xmlns:a16="http://schemas.microsoft.com/office/drawing/2014/main" id="{67E90182-F5E4-1BB7-56D0-269D002BD36F}"/>
+              </a:ext>
+            </a:extLst>
+          </p:cNvPr>
           <p:cNvSpPr>
             <a:spLocks noGrp="1"/>
           </p:cNvSpPr>
@@ -1699,7 +1827,13 @@
       </p:sp>
       <p:sp>
         <p:nvSpPr>
-          <p:cNvPr id="4" name="Slide Number Placeholder 3"/>
+          <p:cNvPr id="4" name="Slide Number Placeholder 3">
+            <a:extLst>
+              <a:ext uri="{FF2B5EF4-FFF2-40B4-BE49-F238E27FC236}">
+                <a16:creationId xmlns:a16="http://schemas.microsoft.com/office/drawing/2014/main" id="{4D24010F-E1D2-7220-E9EC-FB7B103905E2}"/>
+              </a:ext>
+            </a:extLst>
+          </p:cNvPr>
           <p:cNvSpPr>
             <a:spLocks noGrp="1"/>
           </p:cNvSpPr>
@@ -1723,7 +1857,7 @@
     </p:spTree>
     <p:extLst>
       <p:ext uri="{BB962C8B-B14F-4D97-AF65-F5344CB8AC3E}">
-        <p14:creationId xmlns:p14="http://schemas.microsoft.com/office/powerpoint/2010/main" val="2224420856"/>
+        <p14:creationId xmlns:p14="http://schemas.microsoft.com/office/powerpoint/2010/main" val="1668403897"/>
       </p:ext>
     </p:extLst>
   </p:cSld>
@@ -1830,6 +1964,90 @@
         </p:spPr>
       </p:sp>
     </p:spTree>
+  </p:cSld>
+  <p:clrMapOvr>
+    <a:masterClrMapping/>
+  </p:clrMapOvr>
+</p:notes>
+</file>
+
+<file path=ppt/notesSlides/notesSlide20.xml><?xml version="1.0" encoding="utf-8"?>
+<p:notes xmlns:a="http://schemas.openxmlformats.org/drawingml/2006/main" xmlns:r="http://schemas.openxmlformats.org/officeDocument/2006/relationships" xmlns:p="http://schemas.openxmlformats.org/presentationml/2006/main">
+  <p:cSld>
+    <p:spTree>
+      <p:nvGrpSpPr>
+        <p:cNvPr id="1" name=""/>
+        <p:cNvGrpSpPr/>
+        <p:nvPr/>
+      </p:nvGrpSpPr>
+      <p:grpSpPr>
+        <a:xfrm>
+          <a:off x="0" y="0"/>
+          <a:ext cx="0" cy="0"/>
+          <a:chOff x="0" y="0"/>
+          <a:chExt cx="0" cy="0"/>
+        </a:xfrm>
+      </p:grpSpPr>
+      <p:sp>
+        <p:nvSpPr>
+          <p:cNvPr id="2" name="Slide Image Placeholder 1"/>
+          <p:cNvSpPr>
+            <a:spLocks noGrp="1" noRot="1" noChangeAspect="1"/>
+          </p:cNvSpPr>
+          <p:nvPr>
+            <p:ph type="sldImg"/>
+          </p:nvPr>
+        </p:nvSpPr>
+        <p:spPr/>
+      </p:sp>
+      <p:sp>
+        <p:nvSpPr>
+          <p:cNvPr id="3" name="Notes Placeholder 2"/>
+          <p:cNvSpPr>
+            <a:spLocks noGrp="1"/>
+          </p:cNvSpPr>
+          <p:nvPr>
+            <p:ph type="body" idx="1"/>
+          </p:nvPr>
+        </p:nvSpPr>
+        <p:spPr/>
+        <p:txBody>
+          <a:bodyPr/>
+          <a:lstStyle/>
+          <a:p>
+            <a:endParaRPr lang="en-US" dirty="0"/>
+          </a:p>
+        </p:txBody>
+      </p:sp>
+      <p:sp>
+        <p:nvSpPr>
+          <p:cNvPr id="4" name="Slide Number Placeholder 3"/>
+          <p:cNvSpPr>
+            <a:spLocks noGrp="1"/>
+          </p:cNvSpPr>
+          <p:nvPr>
+            <p:ph type="sldNum" sz="quarter" idx="5"/>
+          </p:nvPr>
+        </p:nvSpPr>
+        <p:spPr/>
+        <p:txBody>
+          <a:bodyPr/>
+          <a:lstStyle/>
+          <a:p>
+            <a:fld id="{6EC30964-BF55-46F8-B0CF-231697E08BCE}" type="slidenum">
+              <a:rPr lang="en-US" smtClean="0"/>
+              <a:t>24</a:t>
+            </a:fld>
+            <a:endParaRPr lang="en-US" dirty="0"/>
+          </a:p>
+        </p:txBody>
+      </p:sp>
+    </p:spTree>
+    <p:extLst>
+      <p:ext uri="{BB962C8B-B14F-4D97-AF65-F5344CB8AC3E}">
+        <p14:creationId xmlns:p14="http://schemas.microsoft.com/office/powerpoint/2010/main" val="2224420856"/>
+      </p:ext>
+    </p:extLst>
   </p:cSld>
   <p:clrMapOvr>
     <a:masterClrMapping/>
@@ -3155,7 +3373,7 @@
           <a:p>
             <a:fld id="{13BAEBB3-6971-4A70-B89F-25B2367A9074}" type="datetime1">
               <a:rPr lang="en-US" smtClean="0"/>
-              <a:t>2/25/26</a:t>
+              <a:t>3/6/26</a:t>
             </a:fld>
             <a:endParaRPr lang="en-US" dirty="0"/>
           </a:p>
@@ -4623,7 +4841,7 @@
           <a:p>
             <a:fld id="{C3BDA32F-590A-4697-8F2D-A68EAF38203E}" type="datetime1">
               <a:rPr lang="en-US" smtClean="0"/>
-              <a:t>2/25/26</a:t>
+              <a:t>3/6/26</a:t>
             </a:fld>
             <a:endParaRPr lang="en-US" dirty="0"/>
           </a:p>
@@ -4880,7 +5098,7 @@
           <a:p>
             <a:fld id="{9A7F1598-5EA3-4E97-ACD3-F83DF8477C4A}" type="datetime1">
               <a:rPr lang="en-US" smtClean="0"/>
-              <a:t>2/25/26</a:t>
+              <a:t>3/6/26</a:t>
             </a:fld>
             <a:endParaRPr lang="en-US" dirty="0"/>
           </a:p>
@@ -5231,7 +5449,7 @@
           <a:p>
             <a:fld id="{7D745CFD-B34B-479A-81E1-67FE7247FD66}" type="datetime1">
               <a:rPr lang="en-US" smtClean="0"/>
-              <a:t>2/25/26</a:t>
+              <a:t>3/6/26</a:t>
             </a:fld>
             <a:endParaRPr lang="en-US" dirty="0"/>
           </a:p>
@@ -5635,7 +5853,7 @@
           <a:p>
             <a:fld id="{AEA37BA4-C72F-4A27-9BC5-FD1279A76017}" type="datetime1">
               <a:rPr lang="en-US" smtClean="0"/>
-              <a:t>2/25/26</a:t>
+              <a:t>3/6/26</a:t>
             </a:fld>
             <a:endParaRPr lang="en-US" dirty="0"/>
           </a:p>
@@ -6184,7 +6402,7 @@
           <a:p>
             <a:fld id="{CFE65604-446E-4C5B-8E6A-D22F0272134F}" type="datetime1">
               <a:rPr lang="en-US" smtClean="0"/>
-              <a:t>2/25/26</a:t>
+              <a:t>3/6/26</a:t>
             </a:fld>
             <a:endParaRPr lang="pl-PL"/>
           </a:p>
@@ -6577,7 +6795,7 @@
           <a:p>
             <a:fld id="{4F83FD69-A134-4906-BD8F-4FBC2E34E36B}" type="datetime1">
               <a:rPr lang="en-US" smtClean="0"/>
-              <a:t>2/25/26</a:t>
+              <a:t>3/6/26</a:t>
             </a:fld>
             <a:endParaRPr lang="en-US" dirty="0"/>
           </a:p>
@@ -6834,7 +7052,7 @@
           <a:p>
             <a:fld id="{CC474F0B-8000-427F-8495-35BE1F18D2E6}" type="datetime1">
               <a:rPr lang="en-US" smtClean="0"/>
-              <a:t>2/25/26</a:t>
+              <a:t>3/6/26</a:t>
             </a:fld>
             <a:endParaRPr lang="en-US" dirty="0"/>
           </a:p>
@@ -6956,7 +7174,7 @@
           <a:p>
             <a:fld id="{FBF538EA-53CD-44AF-AD56-3A7BEBF6D5E8}" type="datetime1">
               <a:rPr lang="en-US" smtClean="0"/>
-              <a:t>2/25/26</a:t>
+              <a:t>3/6/26</a:t>
             </a:fld>
             <a:endParaRPr lang="en-US" dirty="0"/>
           </a:p>
@@ -7126,7 +7344,7 @@
           <a:p>
             <a:fld id="{AF2F3E90-C67B-41C3-BD86-9C10C4AD1709}" type="datetime1">
               <a:rPr lang="en-US" smtClean="0"/>
-              <a:t>2/25/26</a:t>
+              <a:t>3/6/26</a:t>
             </a:fld>
             <a:endParaRPr lang="en-US" dirty="0"/>
           </a:p>
@@ -7363,7 +7581,7 @@
           <a:p>
             <a:fld id="{038C5E2B-9FEF-40E2-9313-396D2AA347D8}" type="datetime1">
               <a:rPr lang="en-US" smtClean="0"/>
-              <a:t>2/25/26</a:t>
+              <a:t>3/6/26</a:t>
             </a:fld>
             <a:endParaRPr lang="en-US" dirty="0"/>
           </a:p>
@@ -9370,7 +9588,7 @@
           <a:p>
             <a:fld id="{67951538-CE6F-464E-8254-12A37F504BE6}" type="datetime1">
               <a:rPr lang="en-US" smtClean="0"/>
-              <a:t>2/25/26</a:t>
+              <a:t>3/6/26</a:t>
             </a:fld>
             <a:endParaRPr lang="en-US" dirty="0"/>
           </a:p>
@@ -11521,7 +11739,7 @@
           <a:p>
             <a:fld id="{6366BB5E-0EF1-4D18-9535-B9DF778D1AAF}" type="datetime1">
               <a:rPr lang="en-US" smtClean="0"/>
-              <a:t>2/25/26</a:t>
+              <a:t>3/6/26</a:t>
             </a:fld>
             <a:endParaRPr lang="en-US" dirty="0"/>
           </a:p>
@@ -11950,7 +12168,7 @@
           <a:p>
             <a:fld id="{0EE209E0-57A7-4F60-98FD-90D29FC571BB}" type="datetime1">
               <a:rPr lang="en-US" smtClean="0"/>
-              <a:t>2/25/26</a:t>
+              <a:t>3/6/26</a:t>
             </a:fld>
             <a:endParaRPr lang="en-US" dirty="0"/>
           </a:p>
@@ -12107,7 +12325,7 @@
           <a:p>
             <a:fld id="{AB422423-B7E0-4EF6-BACE-D854976A4F63}" type="datetime1">
               <a:rPr lang="en-US" smtClean="0"/>
-              <a:t>2/25/26</a:t>
+              <a:t>3/6/26</a:t>
             </a:fld>
             <a:endParaRPr lang="en-US" dirty="0"/>
           </a:p>
@@ -12573,7 +12791,7 @@
           <a:p>
             <a:fld id="{00C93DA4-5FD1-4899-9730-11C3C443E437}" type="datetime1">
               <a:rPr lang="en-US" smtClean="0"/>
-              <a:t>2/25/26</a:t>
+              <a:t>3/6/26</a:t>
             </a:fld>
             <a:endParaRPr lang="en-US" dirty="0"/>
           </a:p>
@@ -12823,7 +13041,7 @@
           <a:p>
             <a:fld id="{6B4285BE-3472-427D-9394-DE527CF46C66}" type="datetime1">
               <a:rPr lang="en-US" smtClean="0"/>
-              <a:t>2/25/26</a:t>
+              <a:t>3/6/26</a:t>
             </a:fld>
             <a:endParaRPr lang="en-US" dirty="0"/>
           </a:p>
@@ -13064,7 +13282,7 @@
           <a:p>
             <a:fld id="{699B0009-118B-4ADF-BBC9-A724267EBA81}" type="datetime1">
               <a:rPr lang="en-US" smtClean="0"/>
-              <a:t>2/25/26</a:t>
+              <a:t>3/6/26</a:t>
             </a:fld>
             <a:endParaRPr lang="en-US" dirty="0"/>
           </a:p>
@@ -26186,6 +26404,1909 @@
         <p:cNvPr id="1" name="">
           <a:extLst>
             <a:ext uri="{FF2B5EF4-FFF2-40B4-BE49-F238E27FC236}">
+              <a16:creationId xmlns:a16="http://schemas.microsoft.com/office/drawing/2014/main" id="{D73A1BB6-1BD3-1C65-5EC8-BE449A9E9875}"/>
+            </a:ext>
+          </a:extLst>
+        </p:cNvPr>
+        <p:cNvGrpSpPr/>
+        <p:nvPr/>
+      </p:nvGrpSpPr>
+      <p:grpSpPr>
+        <a:xfrm>
+          <a:off x="0" y="0"/>
+          <a:ext cx="0" cy="0"/>
+          <a:chOff x="0" y="0"/>
+          <a:chExt cx="0" cy="0"/>
+        </a:xfrm>
+      </p:grpSpPr>
+      <p:sp>
+        <p:nvSpPr>
+          <p:cNvPr id="6" name="Rounded Rectangle 5">
+            <a:extLst>
+              <a:ext uri="{FF2B5EF4-FFF2-40B4-BE49-F238E27FC236}">
+                <a16:creationId xmlns:a16="http://schemas.microsoft.com/office/drawing/2014/main" id="{AC484C93-BA34-B39B-B206-81C3661F08B5}"/>
+              </a:ext>
+            </a:extLst>
+          </p:cNvPr>
+          <p:cNvSpPr/>
+          <p:nvPr/>
+        </p:nvSpPr>
+        <p:spPr>
+          <a:xfrm>
+            <a:off x="6276884" y="677227"/>
+            <a:ext cx="5549900" cy="5503546"/>
+          </a:xfrm>
+          <a:prstGeom prst="roundRect">
+            <a:avLst>
+              <a:gd name="adj" fmla="val 5855"/>
+            </a:avLst>
+          </a:prstGeom>
+          <a:solidFill>
+            <a:schemeClr val="bg1">
+              <a:lumMod val="95000"/>
+            </a:schemeClr>
+          </a:solidFill>
+          <a:ln>
+            <a:noFill/>
+          </a:ln>
+        </p:spPr>
+        <p:style>
+          <a:lnRef idx="2">
+            <a:schemeClr val="accent1">
+              <a:shade val="50000"/>
+            </a:schemeClr>
+          </a:lnRef>
+          <a:fillRef idx="1">
+            <a:schemeClr val="accent1"/>
+          </a:fillRef>
+          <a:effectRef idx="0">
+            <a:schemeClr val="accent1"/>
+          </a:effectRef>
+          <a:fontRef idx="minor">
+            <a:schemeClr val="lt1"/>
+          </a:fontRef>
+        </p:style>
+        <p:txBody>
+          <a:bodyPr tIns="72000" bIns="72000" rtlCol="0" anchor="ctr"/>
+          <a:lstStyle/>
+          <a:p>
+            <a:pPr algn="ctr">
+              <a:spcAft>
+                <a:spcPts val="600"/>
+              </a:spcAft>
+            </a:pPr>
+            <a:endParaRPr lang="en-US" dirty="0"/>
+          </a:p>
+        </p:txBody>
+      </p:sp>
+      <p:sp>
+        <p:nvSpPr>
+          <p:cNvPr id="2" name="Title 1">
+            <a:extLst>
+              <a:ext uri="{FF2B5EF4-FFF2-40B4-BE49-F238E27FC236}">
+                <a16:creationId xmlns:a16="http://schemas.microsoft.com/office/drawing/2014/main" id="{C9F4CA9C-8774-C779-7255-6F4931ED92E1}"/>
+              </a:ext>
+            </a:extLst>
+          </p:cNvPr>
+          <p:cNvSpPr>
+            <a:spLocks noGrp="1"/>
+          </p:cNvSpPr>
+          <p:nvPr>
+            <p:ph type="title"/>
+          </p:nvPr>
+        </p:nvSpPr>
+        <p:spPr>
+          <a:xfrm>
+            <a:off x="1077685" y="288610"/>
+            <a:ext cx="10243457" cy="788191"/>
+          </a:xfrm>
+        </p:spPr>
+        <p:txBody>
+          <a:bodyPr>
+            <a:normAutofit/>
+          </a:bodyPr>
+          <a:lstStyle/>
+          <a:p>
+            <a:r>
+              <a:rPr lang="en-US" dirty="0"/>
+              <a:t>Quarto Front Matter</a:t>
+            </a:r>
+            <a:endParaRPr lang="en-US" dirty="0">
+              <a:latin typeface="Courier New" panose="02070309020205020404" pitchFamily="49" charset="0"/>
+              <a:cs typeface="Courier New" panose="02070309020205020404" pitchFamily="49" charset="0"/>
+            </a:endParaRPr>
+          </a:p>
+        </p:txBody>
+      </p:sp>
+      <p:sp>
+        <p:nvSpPr>
+          <p:cNvPr id="3" name="Footer Placeholder 2">
+            <a:extLst>
+              <a:ext uri="{FF2B5EF4-FFF2-40B4-BE49-F238E27FC236}">
+                <a16:creationId xmlns:a16="http://schemas.microsoft.com/office/drawing/2014/main" id="{CF07B1CC-24B3-4448-95E9-BA81AA479F1A}"/>
+              </a:ext>
+            </a:extLst>
+          </p:cNvPr>
+          <p:cNvSpPr>
+            <a:spLocks noGrp="1"/>
+          </p:cNvSpPr>
+          <p:nvPr>
+            <p:ph type="ftr" sz="quarter" idx="11"/>
+          </p:nvPr>
+        </p:nvSpPr>
+        <p:spPr/>
+        <p:txBody>
+          <a:bodyPr/>
+          <a:lstStyle/>
+          <a:p>
+            <a:endParaRPr lang="en-US" dirty="0"/>
+          </a:p>
+        </p:txBody>
+      </p:sp>
+      <p:sp>
+        <p:nvSpPr>
+          <p:cNvPr id="4" name="Slide Number Placeholder 3">
+            <a:extLst>
+              <a:ext uri="{FF2B5EF4-FFF2-40B4-BE49-F238E27FC236}">
+                <a16:creationId xmlns:a16="http://schemas.microsoft.com/office/drawing/2014/main" id="{D9B14298-BFE1-C438-B776-AF4A3DF02E64}"/>
+              </a:ext>
+            </a:extLst>
+          </p:cNvPr>
+          <p:cNvSpPr>
+            <a:spLocks noGrp="1"/>
+          </p:cNvSpPr>
+          <p:nvPr>
+            <p:ph type="sldNum" sz="quarter" idx="12"/>
+          </p:nvPr>
+        </p:nvSpPr>
+        <p:spPr/>
+        <p:txBody>
+          <a:bodyPr/>
+          <a:lstStyle/>
+          <a:p>
+            <a:fld id="{FFA67747-A1D0-4850-AF9A-570B1A0E3F7F}" type="slidenum">
+              <a:rPr lang="en-US" smtClean="0"/>
+              <a:pPr/>
+              <a:t>18</a:t>
+            </a:fld>
+            <a:endParaRPr lang="en-US" dirty="0"/>
+          </a:p>
+        </p:txBody>
+      </p:sp>
+      <p:sp>
+        <p:nvSpPr>
+          <p:cNvPr id="9" name="Rounded Rectangle 8">
+            <a:extLst>
+              <a:ext uri="{FF2B5EF4-FFF2-40B4-BE49-F238E27FC236}">
+                <a16:creationId xmlns:a16="http://schemas.microsoft.com/office/drawing/2014/main" id="{E6C0FB0E-D93B-6568-AFCA-E91C9F2B96D1}"/>
+              </a:ext>
+            </a:extLst>
+          </p:cNvPr>
+          <p:cNvSpPr/>
+          <p:nvPr/>
+        </p:nvSpPr>
+        <p:spPr>
+          <a:xfrm>
+            <a:off x="6390680" y="1253944"/>
+            <a:ext cx="795932" cy="211474"/>
+          </a:xfrm>
+          <a:prstGeom prst="roundRect">
+            <a:avLst/>
+          </a:prstGeom>
+          <a:solidFill>
+            <a:schemeClr val="accent6">
+              <a:alpha val="50000"/>
+            </a:schemeClr>
+          </a:solidFill>
+          <a:ln>
+            <a:noFill/>
+          </a:ln>
+        </p:spPr>
+        <p:style>
+          <a:lnRef idx="2">
+            <a:schemeClr val="accent1">
+              <a:shade val="50000"/>
+            </a:schemeClr>
+          </a:lnRef>
+          <a:fillRef idx="1">
+            <a:schemeClr val="accent1"/>
+          </a:fillRef>
+          <a:effectRef idx="0">
+            <a:schemeClr val="accent1"/>
+          </a:effectRef>
+          <a:fontRef idx="minor">
+            <a:schemeClr val="lt1"/>
+          </a:fontRef>
+        </p:style>
+        <p:txBody>
+          <a:bodyPr tIns="72000" bIns="72000" rtlCol="0" anchor="ctr"/>
+          <a:lstStyle/>
+          <a:p>
+            <a:pPr algn="ctr">
+              <a:spcAft>
+                <a:spcPts val="600"/>
+              </a:spcAft>
+            </a:pPr>
+            <a:endParaRPr lang="en-US" dirty="0"/>
+          </a:p>
+        </p:txBody>
+      </p:sp>
+      <p:sp>
+        <p:nvSpPr>
+          <p:cNvPr id="10" name="Rounded Rectangle 9">
+            <a:extLst>
+              <a:ext uri="{FF2B5EF4-FFF2-40B4-BE49-F238E27FC236}">
+                <a16:creationId xmlns:a16="http://schemas.microsoft.com/office/drawing/2014/main" id="{C22F9451-A498-6936-38BB-B7D6D456A708}"/>
+              </a:ext>
+            </a:extLst>
+          </p:cNvPr>
+          <p:cNvSpPr/>
+          <p:nvPr/>
+        </p:nvSpPr>
+        <p:spPr>
+          <a:xfrm>
+            <a:off x="6390679" y="1513523"/>
+            <a:ext cx="822960" cy="239532"/>
+          </a:xfrm>
+          <a:prstGeom prst="roundRect">
+            <a:avLst/>
+          </a:prstGeom>
+          <a:solidFill>
+            <a:schemeClr val="accent6">
+              <a:alpha val="50000"/>
+            </a:schemeClr>
+          </a:solidFill>
+          <a:ln>
+            <a:noFill/>
+          </a:ln>
+        </p:spPr>
+        <p:style>
+          <a:lnRef idx="2">
+            <a:schemeClr val="accent1">
+              <a:shade val="50000"/>
+            </a:schemeClr>
+          </a:lnRef>
+          <a:fillRef idx="1">
+            <a:schemeClr val="accent1"/>
+          </a:fillRef>
+          <a:effectRef idx="0">
+            <a:schemeClr val="accent1"/>
+          </a:effectRef>
+          <a:fontRef idx="minor">
+            <a:schemeClr val="lt1"/>
+          </a:fontRef>
+        </p:style>
+        <p:txBody>
+          <a:bodyPr tIns="72000" bIns="72000" rtlCol="0" anchor="ctr"/>
+          <a:lstStyle/>
+          <a:p>
+            <a:pPr algn="ctr">
+              <a:spcAft>
+                <a:spcPts val="600"/>
+              </a:spcAft>
+            </a:pPr>
+            <a:endParaRPr lang="en-US" dirty="0"/>
+          </a:p>
+        </p:txBody>
+      </p:sp>
+      <p:sp>
+        <p:nvSpPr>
+          <p:cNvPr id="11" name="Rounded Rectangle 10">
+            <a:extLst>
+              <a:ext uri="{FF2B5EF4-FFF2-40B4-BE49-F238E27FC236}">
+                <a16:creationId xmlns:a16="http://schemas.microsoft.com/office/drawing/2014/main" id="{ABE0319B-8CA1-C4DD-7479-0182846858DC}"/>
+              </a:ext>
+            </a:extLst>
+          </p:cNvPr>
+          <p:cNvSpPr/>
+          <p:nvPr/>
+        </p:nvSpPr>
+        <p:spPr>
+          <a:xfrm>
+            <a:off x="6390679" y="1966005"/>
+            <a:ext cx="640080" cy="228600"/>
+          </a:xfrm>
+          <a:prstGeom prst="roundRect">
+            <a:avLst/>
+          </a:prstGeom>
+          <a:solidFill>
+            <a:schemeClr val="accent6">
+              <a:alpha val="50000"/>
+            </a:schemeClr>
+          </a:solidFill>
+          <a:ln>
+            <a:noFill/>
+          </a:ln>
+        </p:spPr>
+        <p:style>
+          <a:lnRef idx="2">
+            <a:schemeClr val="accent1">
+              <a:shade val="50000"/>
+            </a:schemeClr>
+          </a:lnRef>
+          <a:fillRef idx="1">
+            <a:schemeClr val="accent1"/>
+          </a:fillRef>
+          <a:effectRef idx="0">
+            <a:schemeClr val="accent1"/>
+          </a:effectRef>
+          <a:fontRef idx="minor">
+            <a:schemeClr val="lt1"/>
+          </a:fontRef>
+        </p:style>
+        <p:txBody>
+          <a:bodyPr tIns="72000" bIns="72000" rtlCol="0" anchor="ctr"/>
+          <a:lstStyle/>
+          <a:p>
+            <a:pPr algn="ctr">
+              <a:spcAft>
+                <a:spcPts val="600"/>
+              </a:spcAft>
+            </a:pPr>
+            <a:endParaRPr lang="en-US" dirty="0"/>
+          </a:p>
+        </p:txBody>
+      </p:sp>
+      <p:sp>
+        <p:nvSpPr>
+          <p:cNvPr id="12" name="Rounded Rectangle 11">
+            <a:extLst>
+              <a:ext uri="{FF2B5EF4-FFF2-40B4-BE49-F238E27FC236}">
+                <a16:creationId xmlns:a16="http://schemas.microsoft.com/office/drawing/2014/main" id="{C7288166-0762-4F6C-CB08-DCACD719061F}"/>
+              </a:ext>
+            </a:extLst>
+          </p:cNvPr>
+          <p:cNvSpPr/>
+          <p:nvPr/>
+        </p:nvSpPr>
+        <p:spPr>
+          <a:xfrm>
+            <a:off x="6390679" y="2227076"/>
+            <a:ext cx="822960" cy="228600"/>
+          </a:xfrm>
+          <a:prstGeom prst="roundRect">
+            <a:avLst/>
+          </a:prstGeom>
+          <a:solidFill>
+            <a:schemeClr val="accent1">
+              <a:alpha val="50000"/>
+            </a:schemeClr>
+          </a:solidFill>
+          <a:ln>
+            <a:noFill/>
+          </a:ln>
+        </p:spPr>
+        <p:style>
+          <a:lnRef idx="2">
+            <a:schemeClr val="accent1">
+              <a:shade val="50000"/>
+            </a:schemeClr>
+          </a:lnRef>
+          <a:fillRef idx="1">
+            <a:schemeClr val="accent1"/>
+          </a:fillRef>
+          <a:effectRef idx="0">
+            <a:schemeClr val="accent1"/>
+          </a:effectRef>
+          <a:fontRef idx="minor">
+            <a:schemeClr val="lt1"/>
+          </a:fontRef>
+        </p:style>
+        <p:txBody>
+          <a:bodyPr tIns="72000" bIns="72000" rtlCol="0" anchor="ctr"/>
+          <a:lstStyle/>
+          <a:p>
+            <a:pPr algn="ctr">
+              <a:spcAft>
+                <a:spcPts val="600"/>
+              </a:spcAft>
+            </a:pPr>
+            <a:endParaRPr lang="en-US" dirty="0"/>
+          </a:p>
+        </p:txBody>
+      </p:sp>
+      <p:sp>
+        <p:nvSpPr>
+          <p:cNvPr id="17" name="Rounded Rectangle 16">
+            <a:extLst>
+              <a:ext uri="{FF2B5EF4-FFF2-40B4-BE49-F238E27FC236}">
+                <a16:creationId xmlns:a16="http://schemas.microsoft.com/office/drawing/2014/main" id="{F39E0128-DC51-DDFE-B4A0-CA9B80910881}"/>
+              </a:ext>
+            </a:extLst>
+          </p:cNvPr>
+          <p:cNvSpPr/>
+          <p:nvPr/>
+        </p:nvSpPr>
+        <p:spPr>
+          <a:xfrm>
+            <a:off x="6390679" y="3376071"/>
+            <a:ext cx="795932" cy="228600"/>
+          </a:xfrm>
+          <a:prstGeom prst="roundRect">
+            <a:avLst/>
+          </a:prstGeom>
+          <a:solidFill>
+            <a:schemeClr val="accent5">
+              <a:alpha val="50000"/>
+            </a:schemeClr>
+          </a:solidFill>
+          <a:ln>
+            <a:noFill/>
+          </a:ln>
+        </p:spPr>
+        <p:style>
+          <a:lnRef idx="2">
+            <a:schemeClr val="accent1">
+              <a:shade val="50000"/>
+            </a:schemeClr>
+          </a:lnRef>
+          <a:fillRef idx="1">
+            <a:schemeClr val="accent1"/>
+          </a:fillRef>
+          <a:effectRef idx="0">
+            <a:schemeClr val="accent1"/>
+          </a:effectRef>
+          <a:fontRef idx="minor">
+            <a:schemeClr val="lt1"/>
+          </a:fontRef>
+        </p:style>
+        <p:txBody>
+          <a:bodyPr tIns="72000" bIns="72000" rtlCol="0" anchor="ctr"/>
+          <a:lstStyle/>
+          <a:p>
+            <a:pPr algn="ctr">
+              <a:spcAft>
+                <a:spcPts val="600"/>
+              </a:spcAft>
+            </a:pPr>
+            <a:endParaRPr lang="en-US" dirty="0"/>
+          </a:p>
+        </p:txBody>
+      </p:sp>
+      <p:sp>
+        <p:nvSpPr>
+          <p:cNvPr id="18" name="Rounded Rectangle 17">
+            <a:extLst>
+              <a:ext uri="{FF2B5EF4-FFF2-40B4-BE49-F238E27FC236}">
+                <a16:creationId xmlns:a16="http://schemas.microsoft.com/office/drawing/2014/main" id="{D0B4859C-2609-70C8-3C6A-E2F1E09DDE06}"/>
+              </a:ext>
+            </a:extLst>
+          </p:cNvPr>
+          <p:cNvSpPr/>
+          <p:nvPr/>
+        </p:nvSpPr>
+        <p:spPr>
+          <a:xfrm>
+            <a:off x="977355" y="3290696"/>
+            <a:ext cx="1395857" cy="365760"/>
+          </a:xfrm>
+          <a:prstGeom prst="roundRect">
+            <a:avLst/>
+          </a:prstGeom>
+          <a:solidFill>
+            <a:schemeClr val="accent6">
+              <a:alpha val="50000"/>
+            </a:schemeClr>
+          </a:solidFill>
+          <a:ln>
+            <a:noFill/>
+          </a:ln>
+        </p:spPr>
+        <p:style>
+          <a:lnRef idx="2">
+            <a:schemeClr val="accent1">
+              <a:shade val="50000"/>
+            </a:schemeClr>
+          </a:lnRef>
+          <a:fillRef idx="1">
+            <a:schemeClr val="accent1"/>
+          </a:fillRef>
+          <a:effectRef idx="0">
+            <a:schemeClr val="accent1"/>
+          </a:effectRef>
+          <a:fontRef idx="minor">
+            <a:schemeClr val="lt1"/>
+          </a:fontRef>
+        </p:style>
+        <p:txBody>
+          <a:bodyPr tIns="72000" bIns="72000" rtlCol="0" anchor="ctr"/>
+          <a:lstStyle/>
+          <a:p>
+            <a:pPr algn="ctr">
+              <a:spcAft>
+                <a:spcPts val="600"/>
+              </a:spcAft>
+            </a:pPr>
+            <a:endParaRPr lang="en-US" dirty="0"/>
+          </a:p>
+        </p:txBody>
+      </p:sp>
+      <p:sp>
+        <p:nvSpPr>
+          <p:cNvPr id="19" name="Rounded Rectangle 18">
+            <a:extLst>
+              <a:ext uri="{FF2B5EF4-FFF2-40B4-BE49-F238E27FC236}">
+                <a16:creationId xmlns:a16="http://schemas.microsoft.com/office/drawing/2014/main" id="{C51DAA56-D8BD-790A-6438-95B5B6079E0A}"/>
+              </a:ext>
+            </a:extLst>
+          </p:cNvPr>
+          <p:cNvSpPr/>
+          <p:nvPr/>
+        </p:nvSpPr>
+        <p:spPr>
+          <a:xfrm>
+            <a:off x="977355" y="4093193"/>
+            <a:ext cx="2163878" cy="365760"/>
+          </a:xfrm>
+          <a:prstGeom prst="roundRect">
+            <a:avLst/>
+          </a:prstGeom>
+          <a:solidFill>
+            <a:schemeClr val="accent1">
+              <a:alpha val="50000"/>
+            </a:schemeClr>
+          </a:solidFill>
+          <a:ln>
+            <a:noFill/>
+          </a:ln>
+        </p:spPr>
+        <p:style>
+          <a:lnRef idx="2">
+            <a:schemeClr val="accent1">
+              <a:shade val="50000"/>
+            </a:schemeClr>
+          </a:lnRef>
+          <a:fillRef idx="1">
+            <a:schemeClr val="accent1"/>
+          </a:fillRef>
+          <a:effectRef idx="0">
+            <a:schemeClr val="accent1"/>
+          </a:effectRef>
+          <a:fontRef idx="minor">
+            <a:schemeClr val="lt1"/>
+          </a:fontRef>
+        </p:style>
+        <p:txBody>
+          <a:bodyPr tIns="72000" bIns="72000" rtlCol="0" anchor="ctr"/>
+          <a:lstStyle/>
+          <a:p>
+            <a:pPr algn="ctr">
+              <a:spcAft>
+                <a:spcPts val="600"/>
+              </a:spcAft>
+            </a:pPr>
+            <a:endParaRPr lang="en-US" dirty="0"/>
+          </a:p>
+        </p:txBody>
+      </p:sp>
+      <p:sp>
+        <p:nvSpPr>
+          <p:cNvPr id="20" name="TextBox 19">
+            <a:extLst>
+              <a:ext uri="{FF2B5EF4-FFF2-40B4-BE49-F238E27FC236}">
+                <a16:creationId xmlns:a16="http://schemas.microsoft.com/office/drawing/2014/main" id="{EC676C35-D38D-2584-CE6E-96618081534B}"/>
+              </a:ext>
+            </a:extLst>
+          </p:cNvPr>
+          <p:cNvSpPr txBox="1"/>
+          <p:nvPr/>
+        </p:nvSpPr>
+        <p:spPr>
+          <a:xfrm>
+            <a:off x="7396518" y="845329"/>
+            <a:ext cx="727906" cy="308165"/>
+          </a:xfrm>
+          <a:prstGeom prst="rect">
+            <a:avLst/>
+          </a:prstGeom>
+          <a:noFill/>
+        </p:spPr>
+        <p:txBody>
+          <a:bodyPr wrap="square">
+            <a:spAutoFit/>
+          </a:bodyPr>
+          <a:lstStyle/>
+          <a:p>
+            <a:pPr marL="0" indent="0">
+              <a:spcBef>
+                <a:spcPts val="0"/>
+              </a:spcBef>
+              <a:spcAft>
+                <a:spcPts val="0"/>
+              </a:spcAft>
+              <a:buSzPts val="2400"/>
+              <a:buNone/>
+            </a:pPr>
+            <a:r>
+              <a:rPr lang="en-US" sz="1400" dirty="0">
+                <a:latin typeface="Courier New" panose="02070309020205020404" pitchFamily="49" charset="0"/>
+                <a:cs typeface="Courier New" panose="02070309020205020404" pitchFamily="49" charset="0"/>
+              </a:rPr>
+              <a:t>YAML</a:t>
+            </a:r>
+          </a:p>
+        </p:txBody>
+      </p:sp>
+      <p:cxnSp>
+        <p:nvCxnSpPr>
+          <p:cNvPr id="21" name="Curved Connector 20">
+            <a:extLst>
+              <a:ext uri="{FF2B5EF4-FFF2-40B4-BE49-F238E27FC236}">
+                <a16:creationId xmlns:a16="http://schemas.microsoft.com/office/drawing/2014/main" id="{7AB12FD9-F088-8682-1BF3-1133099DEE36}"/>
+              </a:ext>
+            </a:extLst>
+          </p:cNvPr>
+          <p:cNvCxnSpPr>
+            <a:cxnSpLocks/>
+            <a:endCxn id="20" idx="1"/>
+          </p:cNvCxnSpPr>
+          <p:nvPr/>
+        </p:nvCxnSpPr>
+        <p:spPr>
+          <a:xfrm flipV="1">
+            <a:off x="7062652" y="999412"/>
+            <a:ext cx="333866" cy="151118"/>
+          </a:xfrm>
+          <a:prstGeom prst="curvedConnector3">
+            <a:avLst>
+              <a:gd name="adj1" fmla="val 50000"/>
+            </a:avLst>
+          </a:prstGeom>
+          <a:ln w="19050">
+            <a:solidFill>
+              <a:schemeClr val="accent5"/>
+            </a:solidFill>
+            <a:headEnd type="triangle"/>
+            <a:tailEnd type="none"/>
+          </a:ln>
+        </p:spPr>
+        <p:style>
+          <a:lnRef idx="1">
+            <a:schemeClr val="accent1"/>
+          </a:lnRef>
+          <a:fillRef idx="0">
+            <a:schemeClr val="accent1"/>
+          </a:fillRef>
+          <a:effectRef idx="0">
+            <a:schemeClr val="accent1"/>
+          </a:effectRef>
+          <a:fontRef idx="minor">
+            <a:schemeClr val="tx1"/>
+          </a:fontRef>
+        </p:style>
+      </p:cxnSp>
+      <p:sp>
+        <p:nvSpPr>
+          <p:cNvPr id="5" name="Rounded Rectangle 4">
+            <a:extLst>
+              <a:ext uri="{FF2B5EF4-FFF2-40B4-BE49-F238E27FC236}">
+                <a16:creationId xmlns:a16="http://schemas.microsoft.com/office/drawing/2014/main" id="{23AFB240-F230-9692-EDD9-4A84053FDF5E}"/>
+              </a:ext>
+            </a:extLst>
+          </p:cNvPr>
+          <p:cNvSpPr/>
+          <p:nvPr/>
+        </p:nvSpPr>
+        <p:spPr>
+          <a:xfrm>
+            <a:off x="6390679" y="2923262"/>
+            <a:ext cx="914400" cy="209432"/>
+          </a:xfrm>
+          <a:prstGeom prst="roundRect">
+            <a:avLst/>
+          </a:prstGeom>
+          <a:solidFill>
+            <a:schemeClr val="accent1">
+              <a:alpha val="50000"/>
+            </a:schemeClr>
+          </a:solidFill>
+          <a:ln>
+            <a:noFill/>
+          </a:ln>
+        </p:spPr>
+        <p:style>
+          <a:lnRef idx="2">
+            <a:schemeClr val="accent1">
+              <a:shade val="50000"/>
+            </a:schemeClr>
+          </a:lnRef>
+          <a:fillRef idx="1">
+            <a:schemeClr val="accent1"/>
+          </a:fillRef>
+          <a:effectRef idx="0">
+            <a:schemeClr val="accent1"/>
+          </a:effectRef>
+          <a:fontRef idx="minor">
+            <a:schemeClr val="lt1"/>
+          </a:fontRef>
+        </p:style>
+        <p:txBody>
+          <a:bodyPr tIns="72000" bIns="72000" rtlCol="0" anchor="ctr"/>
+          <a:lstStyle/>
+          <a:p>
+            <a:pPr algn="ctr">
+              <a:spcAft>
+                <a:spcPts val="600"/>
+              </a:spcAft>
+            </a:pPr>
+            <a:endParaRPr lang="en-US" dirty="0"/>
+          </a:p>
+        </p:txBody>
+      </p:sp>
+      <p:sp>
+        <p:nvSpPr>
+          <p:cNvPr id="8" name="Rounded Rectangle 7">
+            <a:extLst>
+              <a:ext uri="{FF2B5EF4-FFF2-40B4-BE49-F238E27FC236}">
+                <a16:creationId xmlns:a16="http://schemas.microsoft.com/office/drawing/2014/main" id="{77CDAA08-B2AE-96D9-3BF5-F3470C595278}"/>
+              </a:ext>
+            </a:extLst>
+          </p:cNvPr>
+          <p:cNvSpPr/>
+          <p:nvPr/>
+        </p:nvSpPr>
+        <p:spPr>
+          <a:xfrm>
+            <a:off x="977355" y="4895690"/>
+            <a:ext cx="1276747" cy="365760"/>
+          </a:xfrm>
+          <a:prstGeom prst="roundRect">
+            <a:avLst/>
+          </a:prstGeom>
+          <a:solidFill>
+            <a:schemeClr val="accent5">
+              <a:alpha val="50000"/>
+            </a:schemeClr>
+          </a:solidFill>
+          <a:ln>
+            <a:noFill/>
+          </a:ln>
+        </p:spPr>
+        <p:style>
+          <a:lnRef idx="2">
+            <a:schemeClr val="accent1">
+              <a:shade val="50000"/>
+            </a:schemeClr>
+          </a:lnRef>
+          <a:fillRef idx="1">
+            <a:schemeClr val="accent1"/>
+          </a:fillRef>
+          <a:effectRef idx="0">
+            <a:schemeClr val="accent1"/>
+          </a:effectRef>
+          <a:fontRef idx="minor">
+            <a:schemeClr val="lt1"/>
+          </a:fontRef>
+        </p:style>
+        <p:txBody>
+          <a:bodyPr tIns="72000" bIns="72000" rtlCol="0" anchor="ctr"/>
+          <a:lstStyle/>
+          <a:p>
+            <a:pPr algn="ctr">
+              <a:spcAft>
+                <a:spcPts val="600"/>
+              </a:spcAft>
+            </a:pPr>
+            <a:endParaRPr lang="en-US" dirty="0"/>
+          </a:p>
+        </p:txBody>
+      </p:sp>
+      <p:sp>
+        <p:nvSpPr>
+          <p:cNvPr id="14" name="Google Shape;175;p24">
+            <a:extLst>
+              <a:ext uri="{FF2B5EF4-FFF2-40B4-BE49-F238E27FC236}">
+                <a16:creationId xmlns:a16="http://schemas.microsoft.com/office/drawing/2014/main" id="{1C591A72-A3F5-7436-1D59-D8796772C764}"/>
+              </a:ext>
+            </a:extLst>
+          </p:cNvPr>
+          <p:cNvSpPr txBox="1">
+            <a:spLocks/>
+          </p:cNvSpPr>
+          <p:nvPr/>
+        </p:nvSpPr>
+        <p:spPr>
+          <a:xfrm>
+            <a:off x="695325" y="1216823"/>
+            <a:ext cx="4937760" cy="4557443"/>
+          </a:xfrm>
+          <a:prstGeom prst="rect">
+            <a:avLst/>
+          </a:prstGeom>
+          <a:noFill/>
+          <a:ln>
+            <a:noFill/>
+          </a:ln>
+        </p:spPr>
+        <p:txBody>
+          <a:bodyPr spcFirstLastPara="1" vert="horz" wrap="square" lIns="91425" tIns="45700" rIns="91425" bIns="45700" rtlCol="0" anchor="t" anchorCtr="0">
+            <a:noAutofit/>
+          </a:bodyPr>
+          <a:lstStyle>
+            <a:lvl1pPr marL="228594" indent="-228594" algn="l" defTabSz="914377" rtl="0" eaLnBrk="1" latinLnBrk="0" hangingPunct="1">
+              <a:lnSpc>
+                <a:spcPct val="110000"/>
+              </a:lnSpc>
+              <a:spcBef>
+                <a:spcPts val="1000"/>
+              </a:spcBef>
+              <a:spcAft>
+                <a:spcPts val="600"/>
+              </a:spcAft>
+              <a:buClrTx/>
+              <a:buFont typeface="Arial" panose="020B0604020202020204" pitchFamily="34" charset="0"/>
+              <a:buChar char="•"/>
+              <a:defRPr sz="2400" kern="1200">
+                <a:solidFill>
+                  <a:schemeClr val="tx1"/>
+                </a:solidFill>
+                <a:latin typeface="Arial" panose="020B0604020202020204" pitchFamily="34" charset="0"/>
+                <a:ea typeface="+mn-ea"/>
+                <a:cs typeface="Arial" panose="020B0604020202020204" pitchFamily="34" charset="0"/>
+              </a:defRPr>
+            </a:lvl1pPr>
+            <a:lvl2pPr marL="542912" indent="-228594" algn="l" defTabSz="914377" rtl="0" eaLnBrk="1" latinLnBrk="0" hangingPunct="1">
+              <a:lnSpc>
+                <a:spcPct val="110000"/>
+              </a:lnSpc>
+              <a:spcBef>
+                <a:spcPts val="500"/>
+              </a:spcBef>
+              <a:spcAft>
+                <a:spcPts val="600"/>
+              </a:spcAft>
+              <a:buClrTx/>
+              <a:buFont typeface="Arial" panose="020B0604020202020204" pitchFamily="34" charset="0"/>
+              <a:buChar char="•"/>
+              <a:defRPr sz="2000" kern="1200">
+                <a:solidFill>
+                  <a:schemeClr val="tx1"/>
+                </a:solidFill>
+                <a:latin typeface="Arial" panose="020B0604020202020204" pitchFamily="34" charset="0"/>
+                <a:ea typeface="+mn-ea"/>
+                <a:cs typeface="Arial" panose="020B0604020202020204" pitchFamily="34" charset="0"/>
+              </a:defRPr>
+            </a:lvl2pPr>
+            <a:lvl3pPr marL="895328" indent="-228594" algn="l" defTabSz="914377" rtl="0" eaLnBrk="1" latinLnBrk="0" hangingPunct="1">
+              <a:lnSpc>
+                <a:spcPct val="110000"/>
+              </a:lnSpc>
+              <a:spcBef>
+                <a:spcPts val="500"/>
+              </a:spcBef>
+              <a:spcAft>
+                <a:spcPts val="600"/>
+              </a:spcAft>
+              <a:buClrTx/>
+              <a:buFont typeface="Arial" panose="020B0604020202020204" pitchFamily="34" charset="0"/>
+              <a:buChar char="•"/>
+              <a:defRPr sz="1800" kern="1200">
+                <a:solidFill>
+                  <a:schemeClr val="tx1"/>
+                </a:solidFill>
+                <a:latin typeface="Arial" panose="020B0604020202020204" pitchFamily="34" charset="0"/>
+                <a:ea typeface="+mn-ea"/>
+                <a:cs typeface="Arial" panose="020B0604020202020204" pitchFamily="34" charset="0"/>
+              </a:defRPr>
+            </a:lvl3pPr>
+            <a:lvl4pPr marL="1257269" indent="-228594" algn="l" defTabSz="914377" rtl="0" eaLnBrk="1" latinLnBrk="0" hangingPunct="1">
+              <a:lnSpc>
+                <a:spcPct val="110000"/>
+              </a:lnSpc>
+              <a:spcBef>
+                <a:spcPts val="500"/>
+              </a:spcBef>
+              <a:spcAft>
+                <a:spcPts val="600"/>
+              </a:spcAft>
+              <a:buClrTx/>
+              <a:buFont typeface="Arial" panose="020B0604020202020204" pitchFamily="34" charset="0"/>
+              <a:buChar char="•"/>
+              <a:defRPr sz="1600" kern="1200">
+                <a:solidFill>
+                  <a:schemeClr val="tx1"/>
+                </a:solidFill>
+                <a:latin typeface="Arial" panose="020B0604020202020204" pitchFamily="34" charset="0"/>
+                <a:ea typeface="+mn-ea"/>
+                <a:cs typeface="Arial" panose="020B0604020202020204" pitchFamily="34" charset="0"/>
+              </a:defRPr>
+            </a:lvl4pPr>
+            <a:lvl5pPr marL="1619210" indent="-228594" algn="l" defTabSz="914377" rtl="0" eaLnBrk="1" latinLnBrk="0" hangingPunct="1">
+              <a:lnSpc>
+                <a:spcPct val="110000"/>
+              </a:lnSpc>
+              <a:spcBef>
+                <a:spcPts val="500"/>
+              </a:spcBef>
+              <a:spcAft>
+                <a:spcPts val="600"/>
+              </a:spcAft>
+              <a:buClrTx/>
+              <a:buFont typeface="Arial" panose="020B0604020202020204" pitchFamily="34" charset="0"/>
+              <a:buChar char="•"/>
+              <a:tabLst>
+                <a:tab pos="1619210" algn="l"/>
+              </a:tabLst>
+              <a:defRPr sz="1600" kern="1200">
+                <a:solidFill>
+                  <a:schemeClr val="tx1"/>
+                </a:solidFill>
+                <a:latin typeface="Arial" panose="020B0604020202020204" pitchFamily="34" charset="0"/>
+                <a:ea typeface="+mn-ea"/>
+                <a:cs typeface="Arial" panose="020B0604020202020204" pitchFamily="34" charset="0"/>
+              </a:defRPr>
+            </a:lvl5pPr>
+            <a:lvl6pPr marL="2514537" indent="-228594" algn="l" defTabSz="914377" rtl="0" eaLnBrk="1" latinLnBrk="0" hangingPunct="1">
+              <a:lnSpc>
+                <a:spcPct val="90000"/>
+              </a:lnSpc>
+              <a:spcBef>
+                <a:spcPts val="500"/>
+              </a:spcBef>
+              <a:buFont typeface="Arial" panose="020B0604020202020204" pitchFamily="34" charset="0"/>
+              <a:buChar char="•"/>
+              <a:defRPr sz="1800" kern="1200">
+                <a:solidFill>
+                  <a:schemeClr val="tx1"/>
+                </a:solidFill>
+                <a:latin typeface="+mn-lt"/>
+                <a:ea typeface="+mn-ea"/>
+                <a:cs typeface="+mn-cs"/>
+              </a:defRPr>
+            </a:lvl6pPr>
+            <a:lvl7pPr marL="2971726" indent="-228594" algn="l" defTabSz="914377" rtl="0" eaLnBrk="1" latinLnBrk="0" hangingPunct="1">
+              <a:lnSpc>
+                <a:spcPct val="90000"/>
+              </a:lnSpc>
+              <a:spcBef>
+                <a:spcPts val="500"/>
+              </a:spcBef>
+              <a:buFont typeface="Arial" panose="020B0604020202020204" pitchFamily="34" charset="0"/>
+              <a:buChar char="•"/>
+              <a:defRPr sz="1800" kern="1200">
+                <a:solidFill>
+                  <a:schemeClr val="tx1"/>
+                </a:solidFill>
+                <a:latin typeface="+mn-lt"/>
+                <a:ea typeface="+mn-ea"/>
+                <a:cs typeface="+mn-cs"/>
+              </a:defRPr>
+            </a:lvl7pPr>
+            <a:lvl8pPr marL="3428914" indent="-228594" algn="l" defTabSz="914377" rtl="0" eaLnBrk="1" latinLnBrk="0" hangingPunct="1">
+              <a:lnSpc>
+                <a:spcPct val="90000"/>
+              </a:lnSpc>
+              <a:spcBef>
+                <a:spcPts val="500"/>
+              </a:spcBef>
+              <a:buFont typeface="Arial" panose="020B0604020202020204" pitchFamily="34" charset="0"/>
+              <a:buChar char="•"/>
+              <a:defRPr sz="1800" kern="1200">
+                <a:solidFill>
+                  <a:schemeClr val="tx1"/>
+                </a:solidFill>
+                <a:latin typeface="+mn-lt"/>
+                <a:ea typeface="+mn-ea"/>
+                <a:cs typeface="+mn-cs"/>
+              </a:defRPr>
+            </a:lvl8pPr>
+            <a:lvl9pPr marL="3886103" indent="-228594" algn="l" defTabSz="914377" rtl="0" eaLnBrk="1" latinLnBrk="0" hangingPunct="1">
+              <a:lnSpc>
+                <a:spcPct val="90000"/>
+              </a:lnSpc>
+              <a:spcBef>
+                <a:spcPts val="500"/>
+              </a:spcBef>
+              <a:buFont typeface="Arial" panose="020B0604020202020204" pitchFamily="34" charset="0"/>
+              <a:buChar char="•"/>
+              <a:defRPr sz="1800" kern="1200">
+                <a:solidFill>
+                  <a:schemeClr val="tx1"/>
+                </a:solidFill>
+                <a:latin typeface="+mn-lt"/>
+                <a:ea typeface="+mn-ea"/>
+                <a:cs typeface="+mn-cs"/>
+              </a:defRPr>
+            </a:lvl9pPr>
+          </a:lstStyle>
+          <a:p>
+            <a:pPr marL="0" indent="0">
+              <a:spcBef>
+                <a:spcPts val="0"/>
+              </a:spcBef>
+              <a:spcAft>
+                <a:spcPts val="0"/>
+              </a:spcAft>
+              <a:buSzPts val="2400"/>
+              <a:buNone/>
+            </a:pPr>
+            <a:r>
+              <a:rPr lang="en-US" dirty="0"/>
+              <a:t>Global document configurations and metadata are defined at the start of the document in the </a:t>
+            </a:r>
+            <a:r>
+              <a:rPr lang="en-US" b="1" dirty="0"/>
+              <a:t>front matter.</a:t>
+            </a:r>
+          </a:p>
+          <a:p>
+            <a:pPr marL="0" indent="0">
+              <a:spcBef>
+                <a:spcPts val="0"/>
+              </a:spcBef>
+              <a:spcAft>
+                <a:spcPts val="0"/>
+              </a:spcAft>
+              <a:buSzPts val="2400"/>
+              <a:buNone/>
+            </a:pPr>
+            <a:endParaRPr lang="en-US" b="1" dirty="0"/>
+          </a:p>
+          <a:p>
+            <a:pPr>
+              <a:spcBef>
+                <a:spcPts val="0"/>
+              </a:spcBef>
+              <a:spcAft>
+                <a:spcPts val="0"/>
+              </a:spcAft>
+              <a:buSzPts val="2400"/>
+            </a:pPr>
+            <a:r>
+              <a:rPr lang="en-US" b="1" dirty="0"/>
+              <a:t>Metadata: </a:t>
+            </a:r>
+            <a:r>
+              <a:rPr lang="en-US" dirty="0"/>
+              <a:t>title, author, date, etc.</a:t>
+            </a:r>
+          </a:p>
+          <a:p>
+            <a:pPr>
+              <a:spcBef>
+                <a:spcPts val="0"/>
+              </a:spcBef>
+              <a:spcAft>
+                <a:spcPts val="0"/>
+              </a:spcAft>
+              <a:buSzPts val="2400"/>
+            </a:pPr>
+            <a:endParaRPr lang="en-US" b="1" dirty="0"/>
+          </a:p>
+          <a:p>
+            <a:pPr>
+              <a:spcBef>
+                <a:spcPts val="0"/>
+              </a:spcBef>
+              <a:spcAft>
+                <a:spcPts val="0"/>
+              </a:spcAft>
+              <a:buSzPts val="2400"/>
+            </a:pPr>
+            <a:r>
+              <a:rPr lang="en-US" b="1" dirty="0"/>
+              <a:t>Global Config: </a:t>
+            </a:r>
+            <a:r>
+              <a:rPr lang="en-US" dirty="0"/>
+              <a:t>format, execute, etc.</a:t>
+            </a:r>
+          </a:p>
+          <a:p>
+            <a:pPr>
+              <a:spcBef>
+                <a:spcPts val="0"/>
+              </a:spcBef>
+              <a:spcAft>
+                <a:spcPts val="0"/>
+              </a:spcAft>
+              <a:buSzPts val="2400"/>
+            </a:pPr>
+            <a:r>
+              <a:rPr lang="en-US" b="1" dirty="0"/>
+              <a:t>Params: </a:t>
+            </a:r>
+            <a:r>
+              <a:rPr lang="en-US" dirty="0"/>
+              <a:t>custom fields</a:t>
+            </a:r>
+          </a:p>
+          <a:p>
+            <a:pPr>
+              <a:spcBef>
+                <a:spcPts val="0"/>
+              </a:spcBef>
+              <a:spcAft>
+                <a:spcPts val="0"/>
+              </a:spcAft>
+              <a:buSzPts val="2400"/>
+            </a:pPr>
+            <a:endParaRPr lang="en-US" b="1" dirty="0"/>
+          </a:p>
+        </p:txBody>
+      </p:sp>
+      <p:sp>
+        <p:nvSpPr>
+          <p:cNvPr id="22" name="TextBox 21">
+            <a:extLst>
+              <a:ext uri="{FF2B5EF4-FFF2-40B4-BE49-F238E27FC236}">
+                <a16:creationId xmlns:a16="http://schemas.microsoft.com/office/drawing/2014/main" id="{568A7F52-07CD-1BED-FB7B-ED97A90BDAE4}"/>
+              </a:ext>
+            </a:extLst>
+          </p:cNvPr>
+          <p:cNvSpPr txBox="1"/>
+          <p:nvPr/>
+        </p:nvSpPr>
+        <p:spPr>
+          <a:xfrm>
+            <a:off x="4635502" y="5689352"/>
+            <a:ext cx="3027204" cy="738664"/>
+          </a:xfrm>
+          <a:prstGeom prst="rect">
+            <a:avLst/>
+          </a:prstGeom>
+          <a:noFill/>
+        </p:spPr>
+        <p:txBody>
+          <a:bodyPr wrap="square">
+            <a:spAutoFit/>
+          </a:bodyPr>
+          <a:lstStyle/>
+          <a:p>
+            <a:pPr marL="0" indent="0">
+              <a:spcBef>
+                <a:spcPts val="0"/>
+              </a:spcBef>
+              <a:spcAft>
+                <a:spcPts val="0"/>
+              </a:spcAft>
+              <a:buSzPts val="2400"/>
+              <a:buNone/>
+            </a:pPr>
+            <a:r>
+              <a:rPr lang="en-US" sz="1400" dirty="0">
+                <a:latin typeface="Courier New" panose="02070309020205020404" pitchFamily="49" charset="0"/>
+                <a:cs typeface="Courier New" panose="02070309020205020404" pitchFamily="49" charset="0"/>
+              </a:rPr>
+              <a:t>Use short code to reference front matter metadata in the document</a:t>
+            </a:r>
+          </a:p>
+        </p:txBody>
+      </p:sp>
+      <p:cxnSp>
+        <p:nvCxnSpPr>
+          <p:cNvPr id="23" name="Curved Connector 22">
+            <a:extLst>
+              <a:ext uri="{FF2B5EF4-FFF2-40B4-BE49-F238E27FC236}">
+                <a16:creationId xmlns:a16="http://schemas.microsoft.com/office/drawing/2014/main" id="{8C56D1CC-8FE8-3E64-7E05-4B90708104ED}"/>
+              </a:ext>
+            </a:extLst>
+          </p:cNvPr>
+          <p:cNvCxnSpPr>
+            <a:cxnSpLocks/>
+            <a:endCxn id="22" idx="3"/>
+          </p:cNvCxnSpPr>
+          <p:nvPr/>
+        </p:nvCxnSpPr>
+        <p:spPr>
+          <a:xfrm rot="5400000">
+            <a:off x="7601101" y="5610936"/>
+            <a:ext cx="509354" cy="386143"/>
+          </a:xfrm>
+          <a:prstGeom prst="curvedConnector2">
+            <a:avLst/>
+          </a:prstGeom>
+          <a:ln w="19050">
+            <a:solidFill>
+              <a:schemeClr val="accent5"/>
+            </a:solidFill>
+            <a:headEnd type="triangle"/>
+            <a:tailEnd type="none"/>
+          </a:ln>
+        </p:spPr>
+        <p:style>
+          <a:lnRef idx="1">
+            <a:schemeClr val="accent1"/>
+          </a:lnRef>
+          <a:fillRef idx="0">
+            <a:schemeClr val="accent1"/>
+          </a:fillRef>
+          <a:effectRef idx="0">
+            <a:schemeClr val="accent1"/>
+          </a:effectRef>
+          <a:fontRef idx="minor">
+            <a:schemeClr val="tx1"/>
+          </a:fontRef>
+        </p:style>
+      </p:cxnSp>
+      <p:sp>
+        <p:nvSpPr>
+          <p:cNvPr id="7" name="Google Shape;175;p24">
+            <a:extLst>
+              <a:ext uri="{FF2B5EF4-FFF2-40B4-BE49-F238E27FC236}">
+                <a16:creationId xmlns:a16="http://schemas.microsoft.com/office/drawing/2014/main" id="{F4167A15-ED85-C061-F5FF-F0F7C57FAF5D}"/>
+              </a:ext>
+            </a:extLst>
+          </p:cNvPr>
+          <p:cNvSpPr txBox="1">
+            <a:spLocks/>
+          </p:cNvSpPr>
+          <p:nvPr/>
+        </p:nvSpPr>
+        <p:spPr>
+          <a:xfrm>
+            <a:off x="6373772" y="969101"/>
+            <a:ext cx="5310228" cy="4949561"/>
+          </a:xfrm>
+          <a:prstGeom prst="rect">
+            <a:avLst/>
+          </a:prstGeom>
+          <a:noFill/>
+          <a:ln>
+            <a:noFill/>
+          </a:ln>
+        </p:spPr>
+        <p:txBody>
+          <a:bodyPr spcFirstLastPara="1" vert="horz" wrap="square" lIns="91425" tIns="45700" rIns="91425" bIns="45700" rtlCol="0" anchor="t" anchorCtr="0">
+            <a:noAutofit/>
+          </a:bodyPr>
+          <a:lstStyle>
+            <a:lvl1pPr marL="228594" indent="-228594" algn="l" defTabSz="914377" rtl="0" eaLnBrk="1" latinLnBrk="0" hangingPunct="1">
+              <a:lnSpc>
+                <a:spcPct val="110000"/>
+              </a:lnSpc>
+              <a:spcBef>
+                <a:spcPts val="1000"/>
+              </a:spcBef>
+              <a:spcAft>
+                <a:spcPts val="600"/>
+              </a:spcAft>
+              <a:buClrTx/>
+              <a:buFont typeface="Arial" panose="020B0604020202020204" pitchFamily="34" charset="0"/>
+              <a:buChar char="•"/>
+              <a:defRPr sz="2400" kern="1200">
+                <a:solidFill>
+                  <a:schemeClr val="tx1"/>
+                </a:solidFill>
+                <a:latin typeface="Arial" panose="020B0604020202020204" pitchFamily="34" charset="0"/>
+                <a:ea typeface="+mn-ea"/>
+                <a:cs typeface="Arial" panose="020B0604020202020204" pitchFamily="34" charset="0"/>
+              </a:defRPr>
+            </a:lvl1pPr>
+            <a:lvl2pPr marL="542912" indent="-228594" algn="l" defTabSz="914377" rtl="0" eaLnBrk="1" latinLnBrk="0" hangingPunct="1">
+              <a:lnSpc>
+                <a:spcPct val="110000"/>
+              </a:lnSpc>
+              <a:spcBef>
+                <a:spcPts val="500"/>
+              </a:spcBef>
+              <a:spcAft>
+                <a:spcPts val="600"/>
+              </a:spcAft>
+              <a:buClrTx/>
+              <a:buFont typeface="Arial" panose="020B0604020202020204" pitchFamily="34" charset="0"/>
+              <a:buChar char="•"/>
+              <a:defRPr sz="2000" kern="1200">
+                <a:solidFill>
+                  <a:schemeClr val="tx1"/>
+                </a:solidFill>
+                <a:latin typeface="Arial" panose="020B0604020202020204" pitchFamily="34" charset="0"/>
+                <a:ea typeface="+mn-ea"/>
+                <a:cs typeface="Arial" panose="020B0604020202020204" pitchFamily="34" charset="0"/>
+              </a:defRPr>
+            </a:lvl2pPr>
+            <a:lvl3pPr marL="895328" indent="-228594" algn="l" defTabSz="914377" rtl="0" eaLnBrk="1" latinLnBrk="0" hangingPunct="1">
+              <a:lnSpc>
+                <a:spcPct val="110000"/>
+              </a:lnSpc>
+              <a:spcBef>
+                <a:spcPts val="500"/>
+              </a:spcBef>
+              <a:spcAft>
+                <a:spcPts val="600"/>
+              </a:spcAft>
+              <a:buClrTx/>
+              <a:buFont typeface="Arial" panose="020B0604020202020204" pitchFamily="34" charset="0"/>
+              <a:buChar char="•"/>
+              <a:defRPr sz="1800" kern="1200">
+                <a:solidFill>
+                  <a:schemeClr val="tx1"/>
+                </a:solidFill>
+                <a:latin typeface="Arial" panose="020B0604020202020204" pitchFamily="34" charset="0"/>
+                <a:ea typeface="+mn-ea"/>
+                <a:cs typeface="Arial" panose="020B0604020202020204" pitchFamily="34" charset="0"/>
+              </a:defRPr>
+            </a:lvl3pPr>
+            <a:lvl4pPr marL="1257269" indent="-228594" algn="l" defTabSz="914377" rtl="0" eaLnBrk="1" latinLnBrk="0" hangingPunct="1">
+              <a:lnSpc>
+                <a:spcPct val="110000"/>
+              </a:lnSpc>
+              <a:spcBef>
+                <a:spcPts val="500"/>
+              </a:spcBef>
+              <a:spcAft>
+                <a:spcPts val="600"/>
+              </a:spcAft>
+              <a:buClrTx/>
+              <a:buFont typeface="Arial" panose="020B0604020202020204" pitchFamily="34" charset="0"/>
+              <a:buChar char="•"/>
+              <a:defRPr sz="1600" kern="1200">
+                <a:solidFill>
+                  <a:schemeClr val="tx1"/>
+                </a:solidFill>
+                <a:latin typeface="Arial" panose="020B0604020202020204" pitchFamily="34" charset="0"/>
+                <a:ea typeface="+mn-ea"/>
+                <a:cs typeface="Arial" panose="020B0604020202020204" pitchFamily="34" charset="0"/>
+              </a:defRPr>
+            </a:lvl4pPr>
+            <a:lvl5pPr marL="1619210" indent="-228594" algn="l" defTabSz="914377" rtl="0" eaLnBrk="1" latinLnBrk="0" hangingPunct="1">
+              <a:lnSpc>
+                <a:spcPct val="110000"/>
+              </a:lnSpc>
+              <a:spcBef>
+                <a:spcPts val="500"/>
+              </a:spcBef>
+              <a:spcAft>
+                <a:spcPts val="600"/>
+              </a:spcAft>
+              <a:buClrTx/>
+              <a:buFont typeface="Arial" panose="020B0604020202020204" pitchFamily="34" charset="0"/>
+              <a:buChar char="•"/>
+              <a:tabLst>
+                <a:tab pos="1619210" algn="l"/>
+              </a:tabLst>
+              <a:defRPr sz="1600" kern="1200">
+                <a:solidFill>
+                  <a:schemeClr val="tx1"/>
+                </a:solidFill>
+                <a:latin typeface="Arial" panose="020B0604020202020204" pitchFamily="34" charset="0"/>
+                <a:ea typeface="+mn-ea"/>
+                <a:cs typeface="Arial" panose="020B0604020202020204" pitchFamily="34" charset="0"/>
+              </a:defRPr>
+            </a:lvl5pPr>
+            <a:lvl6pPr marL="2514537" indent="-228594" algn="l" defTabSz="914377" rtl="0" eaLnBrk="1" latinLnBrk="0" hangingPunct="1">
+              <a:lnSpc>
+                <a:spcPct val="90000"/>
+              </a:lnSpc>
+              <a:spcBef>
+                <a:spcPts val="500"/>
+              </a:spcBef>
+              <a:buFont typeface="Arial" panose="020B0604020202020204" pitchFamily="34" charset="0"/>
+              <a:buChar char="•"/>
+              <a:defRPr sz="1800" kern="1200">
+                <a:solidFill>
+                  <a:schemeClr val="tx1"/>
+                </a:solidFill>
+                <a:latin typeface="+mn-lt"/>
+                <a:ea typeface="+mn-ea"/>
+                <a:cs typeface="+mn-cs"/>
+              </a:defRPr>
+            </a:lvl6pPr>
+            <a:lvl7pPr marL="2971726" indent="-228594" algn="l" defTabSz="914377" rtl="0" eaLnBrk="1" latinLnBrk="0" hangingPunct="1">
+              <a:lnSpc>
+                <a:spcPct val="90000"/>
+              </a:lnSpc>
+              <a:spcBef>
+                <a:spcPts val="500"/>
+              </a:spcBef>
+              <a:buFont typeface="Arial" panose="020B0604020202020204" pitchFamily="34" charset="0"/>
+              <a:buChar char="•"/>
+              <a:defRPr sz="1800" kern="1200">
+                <a:solidFill>
+                  <a:schemeClr val="tx1"/>
+                </a:solidFill>
+                <a:latin typeface="+mn-lt"/>
+                <a:ea typeface="+mn-ea"/>
+                <a:cs typeface="+mn-cs"/>
+              </a:defRPr>
+            </a:lvl7pPr>
+            <a:lvl8pPr marL="3428914" indent="-228594" algn="l" defTabSz="914377" rtl="0" eaLnBrk="1" latinLnBrk="0" hangingPunct="1">
+              <a:lnSpc>
+                <a:spcPct val="90000"/>
+              </a:lnSpc>
+              <a:spcBef>
+                <a:spcPts val="500"/>
+              </a:spcBef>
+              <a:buFont typeface="Arial" panose="020B0604020202020204" pitchFamily="34" charset="0"/>
+              <a:buChar char="•"/>
+              <a:defRPr sz="1800" kern="1200">
+                <a:solidFill>
+                  <a:schemeClr val="tx1"/>
+                </a:solidFill>
+                <a:latin typeface="+mn-lt"/>
+                <a:ea typeface="+mn-ea"/>
+                <a:cs typeface="+mn-cs"/>
+              </a:defRPr>
+            </a:lvl8pPr>
+            <a:lvl9pPr marL="3886103" indent="-228594" algn="l" defTabSz="914377" rtl="0" eaLnBrk="1" latinLnBrk="0" hangingPunct="1">
+              <a:lnSpc>
+                <a:spcPct val="90000"/>
+              </a:lnSpc>
+              <a:spcBef>
+                <a:spcPts val="500"/>
+              </a:spcBef>
+              <a:buFont typeface="Arial" panose="020B0604020202020204" pitchFamily="34" charset="0"/>
+              <a:buChar char="•"/>
+              <a:defRPr sz="1800" kern="1200">
+                <a:solidFill>
+                  <a:schemeClr val="tx1"/>
+                </a:solidFill>
+                <a:latin typeface="+mn-lt"/>
+                <a:ea typeface="+mn-ea"/>
+                <a:cs typeface="+mn-cs"/>
+              </a:defRPr>
+            </a:lvl9pPr>
+          </a:lstStyle>
+          <a:p>
+            <a:pPr marL="0" indent="0">
+              <a:spcBef>
+                <a:spcPts val="0"/>
+              </a:spcBef>
+              <a:spcAft>
+                <a:spcPts val="0"/>
+              </a:spcAft>
+              <a:buSzPts val="2400"/>
+              <a:buNone/>
+            </a:pPr>
+            <a:r>
+              <a:rPr lang="en-US" sz="1400" dirty="0">
+                <a:latin typeface="Courier New" panose="02070309020205020404" pitchFamily="49" charset="0"/>
+                <a:cs typeface="Courier New" panose="02070309020205020404" pitchFamily="49" charset="0"/>
+              </a:rPr>
+              <a:t>---</a:t>
+            </a:r>
+          </a:p>
+          <a:p>
+            <a:pPr marL="0" indent="0">
+              <a:spcBef>
+                <a:spcPts val="0"/>
+              </a:spcBef>
+              <a:spcAft>
+                <a:spcPts val="0"/>
+              </a:spcAft>
+              <a:buSzPts val="2400"/>
+              <a:buNone/>
+            </a:pPr>
+            <a:r>
+              <a:rPr lang="en-US" sz="1400" b="1" dirty="0">
+                <a:latin typeface="Courier New" panose="02070309020205020404" pitchFamily="49" charset="0"/>
+                <a:cs typeface="Courier New" panose="02070309020205020404" pitchFamily="49" charset="0"/>
+              </a:rPr>
+              <a:t>title</a:t>
+            </a:r>
+            <a:r>
+              <a:rPr lang="en-US" sz="1400" dirty="0">
+                <a:latin typeface="Courier New" panose="02070309020205020404" pitchFamily="49" charset="0"/>
+                <a:cs typeface="Courier New" panose="02070309020205020404" pitchFamily="49" charset="0"/>
+              </a:rPr>
+              <a:t>: “Influenza Report”</a:t>
+            </a:r>
+          </a:p>
+          <a:p>
+            <a:pPr marL="0" indent="0">
+              <a:spcBef>
+                <a:spcPts val="0"/>
+              </a:spcBef>
+              <a:spcAft>
+                <a:spcPts val="0"/>
+              </a:spcAft>
+              <a:buSzPts val="2400"/>
+              <a:buNone/>
+            </a:pPr>
+            <a:r>
+              <a:rPr lang="en-US" sz="1400" b="1" dirty="0">
+                <a:latin typeface="Courier New" panose="02070309020205020404" pitchFamily="49" charset="0"/>
+                <a:cs typeface="Courier New" panose="02070309020205020404" pitchFamily="49" charset="0"/>
+              </a:rPr>
+              <a:t>author</a:t>
+            </a:r>
+            <a:r>
+              <a:rPr lang="en-US" sz="1400" dirty="0">
+                <a:latin typeface="Courier New" panose="02070309020205020404" pitchFamily="49" charset="0"/>
+                <a:cs typeface="Courier New" panose="02070309020205020404" pitchFamily="49" charset="0"/>
+              </a:rPr>
+              <a:t>:</a:t>
+            </a:r>
+          </a:p>
+          <a:p>
+            <a:pPr marL="0" indent="0">
+              <a:spcBef>
+                <a:spcPts val="0"/>
+              </a:spcBef>
+              <a:spcAft>
+                <a:spcPts val="0"/>
+              </a:spcAft>
+              <a:buSzPts val="2400"/>
+              <a:buNone/>
+            </a:pPr>
+            <a:r>
+              <a:rPr lang="en-US" sz="1400" dirty="0">
+                <a:latin typeface="Courier New" panose="02070309020205020404" pitchFamily="49" charset="0"/>
+                <a:cs typeface="Courier New" panose="02070309020205020404" pitchFamily="49" charset="0"/>
+              </a:rPr>
+              <a:t>  - name: Jane Doe</a:t>
+            </a:r>
+          </a:p>
+          <a:p>
+            <a:pPr marL="0" indent="0">
+              <a:spcBef>
+                <a:spcPts val="0"/>
+              </a:spcBef>
+              <a:spcAft>
+                <a:spcPts val="0"/>
+              </a:spcAft>
+              <a:buSzPts val="2400"/>
+              <a:buNone/>
+            </a:pPr>
+            <a:r>
+              <a:rPr lang="en-US" sz="1400" b="1" dirty="0">
+                <a:latin typeface="Courier New" panose="02070309020205020404" pitchFamily="49" charset="0"/>
+                <a:cs typeface="Courier New" panose="02070309020205020404" pitchFamily="49" charset="0"/>
+              </a:rPr>
+              <a:t>date</a:t>
+            </a:r>
+            <a:r>
+              <a:rPr lang="en-US" sz="1400" dirty="0">
+                <a:latin typeface="Courier New" panose="02070309020205020404" pitchFamily="49" charset="0"/>
+                <a:cs typeface="Courier New" panose="02070309020205020404" pitchFamily="49" charset="0"/>
+              </a:rPr>
+              <a:t>: today</a:t>
+            </a:r>
+          </a:p>
+          <a:p>
+            <a:pPr marL="0" indent="0">
+              <a:spcBef>
+                <a:spcPts val="0"/>
+              </a:spcBef>
+              <a:spcAft>
+                <a:spcPts val="0"/>
+              </a:spcAft>
+              <a:buSzPts val="2400"/>
+              <a:buNone/>
+            </a:pPr>
+            <a:r>
+              <a:rPr lang="en-US" sz="1400" b="1" dirty="0">
+                <a:latin typeface="Courier New" panose="02070309020205020404" pitchFamily="49" charset="0"/>
+                <a:cs typeface="Courier New" panose="02070309020205020404" pitchFamily="49" charset="0"/>
+              </a:rPr>
+              <a:t>format:</a:t>
+            </a:r>
+          </a:p>
+          <a:p>
+            <a:pPr marL="0" indent="0">
+              <a:spcBef>
+                <a:spcPts val="0"/>
+              </a:spcBef>
+              <a:spcAft>
+                <a:spcPts val="0"/>
+              </a:spcAft>
+              <a:buSzPts val="2400"/>
+              <a:buNone/>
+            </a:pPr>
+            <a:r>
+              <a:rPr lang="en-US" sz="1400" b="1" dirty="0">
+                <a:latin typeface="Courier New" panose="02070309020205020404" pitchFamily="49" charset="0"/>
+                <a:cs typeface="Courier New" panose="02070309020205020404" pitchFamily="49" charset="0"/>
+              </a:rPr>
+              <a:t>  html:</a:t>
+            </a:r>
+          </a:p>
+          <a:p>
+            <a:pPr marL="0" indent="0">
+              <a:spcBef>
+                <a:spcPts val="0"/>
+              </a:spcBef>
+              <a:spcAft>
+                <a:spcPts val="0"/>
+              </a:spcAft>
+              <a:buSzPts val="2400"/>
+              <a:buNone/>
+            </a:pPr>
+            <a:r>
+              <a:rPr lang="en-US" sz="1400" b="1" dirty="0">
+                <a:latin typeface="Courier New" panose="02070309020205020404" pitchFamily="49" charset="0"/>
+                <a:cs typeface="Courier New" panose="02070309020205020404" pitchFamily="49" charset="0"/>
+              </a:rPr>
+              <a:t>    embed-resources: </a:t>
+            </a:r>
+            <a:r>
+              <a:rPr lang="en-US" sz="1400" dirty="0">
+                <a:latin typeface="Courier New" panose="02070309020205020404" pitchFamily="49" charset="0"/>
+                <a:cs typeface="Courier New" panose="02070309020205020404" pitchFamily="49" charset="0"/>
+              </a:rPr>
+              <a:t>true</a:t>
+            </a:r>
+          </a:p>
+          <a:p>
+            <a:pPr marL="0" indent="0">
+              <a:spcBef>
+                <a:spcPts val="0"/>
+              </a:spcBef>
+              <a:spcAft>
+                <a:spcPts val="0"/>
+              </a:spcAft>
+              <a:buSzPts val="2400"/>
+              <a:buNone/>
+            </a:pPr>
+            <a:r>
+              <a:rPr lang="en-US" sz="1400" b="1" dirty="0">
+                <a:latin typeface="Courier New" panose="02070309020205020404" pitchFamily="49" charset="0"/>
+                <a:cs typeface="Courier New" panose="02070309020205020404" pitchFamily="49" charset="0"/>
+              </a:rPr>
+              <a:t>execute:</a:t>
+            </a:r>
+          </a:p>
+          <a:p>
+            <a:pPr marL="0" indent="0">
+              <a:spcBef>
+                <a:spcPts val="0"/>
+              </a:spcBef>
+              <a:spcAft>
+                <a:spcPts val="0"/>
+              </a:spcAft>
+              <a:buSzPts val="2400"/>
+              <a:buNone/>
+            </a:pPr>
+            <a:r>
+              <a:rPr lang="en-US" sz="1400" dirty="0">
+                <a:latin typeface="Courier New" panose="02070309020205020404" pitchFamily="49" charset="0"/>
+                <a:cs typeface="Courier New" panose="02070309020205020404" pitchFamily="49" charset="0"/>
+              </a:rPr>
+              <a:t>  </a:t>
+            </a:r>
+            <a:r>
+              <a:rPr lang="en-US" sz="1400" b="1" dirty="0">
+                <a:latin typeface="Courier New" panose="02070309020205020404" pitchFamily="49" charset="0"/>
+                <a:cs typeface="Courier New" panose="02070309020205020404" pitchFamily="49" charset="0"/>
+              </a:rPr>
+              <a:t>echo: </a:t>
+            </a:r>
+            <a:r>
+              <a:rPr lang="en-US" sz="1400" dirty="0">
+                <a:latin typeface="Courier New" panose="02070309020205020404" pitchFamily="49" charset="0"/>
+                <a:cs typeface="Courier New" panose="02070309020205020404" pitchFamily="49" charset="0"/>
+              </a:rPr>
+              <a:t>false</a:t>
+            </a:r>
+          </a:p>
+          <a:p>
+            <a:pPr marL="0" indent="0">
+              <a:spcBef>
+                <a:spcPts val="0"/>
+              </a:spcBef>
+              <a:spcAft>
+                <a:spcPts val="0"/>
+              </a:spcAft>
+              <a:buSzPts val="2400"/>
+              <a:buNone/>
+            </a:pPr>
+            <a:r>
+              <a:rPr lang="en-US" sz="1400" b="1" dirty="0">
+                <a:latin typeface="Courier New" panose="02070309020205020404" pitchFamily="49" charset="0"/>
+                <a:cs typeface="Courier New" panose="02070309020205020404" pitchFamily="49" charset="0"/>
+              </a:rPr>
+              <a:t>params:</a:t>
+            </a:r>
+          </a:p>
+          <a:p>
+            <a:pPr marL="0" indent="0">
+              <a:spcBef>
+                <a:spcPts val="0"/>
+              </a:spcBef>
+              <a:spcAft>
+                <a:spcPts val="0"/>
+              </a:spcAft>
+              <a:buSzPts val="2400"/>
+              <a:buNone/>
+            </a:pPr>
+            <a:r>
+              <a:rPr lang="en-US" sz="1400" dirty="0">
+                <a:latin typeface="Courier New" panose="02070309020205020404" pitchFamily="49" charset="0"/>
+                <a:cs typeface="Courier New" panose="02070309020205020404" pitchFamily="49" charset="0"/>
+              </a:rPr>
+              <a:t>  </a:t>
+            </a:r>
+            <a:r>
+              <a:rPr lang="en-US" sz="1400" b="1" dirty="0">
+                <a:latin typeface="Courier New" panose="02070309020205020404" pitchFamily="49" charset="0"/>
+                <a:cs typeface="Courier New" panose="02070309020205020404" pitchFamily="49" charset="0"/>
+              </a:rPr>
+              <a:t>species: </a:t>
+            </a:r>
+            <a:r>
+              <a:rPr lang="en-US" sz="1400" dirty="0">
+                <a:latin typeface="Courier New" panose="02070309020205020404" pitchFamily="49" charset="0"/>
+                <a:cs typeface="Courier New" panose="02070309020205020404" pitchFamily="49" charset="0"/>
+              </a:rPr>
+              <a:t>Influenza A</a:t>
+            </a:r>
+          </a:p>
+          <a:p>
+            <a:pPr marL="0" indent="0">
+              <a:spcBef>
+                <a:spcPts val="0"/>
+              </a:spcBef>
+              <a:spcAft>
+                <a:spcPts val="0"/>
+              </a:spcAft>
+              <a:buSzPts val="2400"/>
+              <a:buNone/>
+            </a:pPr>
+            <a:r>
+              <a:rPr lang="en-US" sz="1400" dirty="0">
+                <a:latin typeface="Courier New" panose="02070309020205020404" pitchFamily="49" charset="0"/>
+                <a:cs typeface="Courier New" panose="02070309020205020404" pitchFamily="49" charset="0"/>
+              </a:rPr>
+              <a:t>  </a:t>
+            </a:r>
+            <a:r>
+              <a:rPr lang="en-US" sz="1400" b="1" dirty="0">
+                <a:latin typeface="Courier New" panose="02070309020205020404" pitchFamily="49" charset="0"/>
+                <a:cs typeface="Courier New" panose="02070309020205020404" pitchFamily="49" charset="0"/>
+              </a:rPr>
+              <a:t>subtype: </a:t>
+            </a:r>
+            <a:r>
+              <a:rPr lang="en-US" sz="1400" dirty="0">
+                <a:latin typeface="Courier New" panose="02070309020205020404" pitchFamily="49" charset="0"/>
+                <a:cs typeface="Courier New" panose="02070309020205020404" pitchFamily="49" charset="0"/>
+              </a:rPr>
+              <a:t>H1N1</a:t>
+            </a:r>
+          </a:p>
+          <a:p>
+            <a:pPr marL="0" indent="0">
+              <a:spcBef>
+                <a:spcPts val="0"/>
+              </a:spcBef>
+              <a:spcAft>
+                <a:spcPts val="0"/>
+              </a:spcAft>
+              <a:buSzPts val="2400"/>
+              <a:buNone/>
+            </a:pPr>
+            <a:r>
+              <a:rPr lang="en-US" sz="1400" dirty="0">
+                <a:latin typeface="Courier New" panose="02070309020205020404" pitchFamily="49" charset="0"/>
+                <a:cs typeface="Courier New" panose="02070309020205020404" pitchFamily="49" charset="0"/>
+              </a:rPr>
+              <a:t>---</a:t>
+            </a:r>
+          </a:p>
+          <a:p>
+            <a:pPr marL="0" indent="0">
+              <a:spcBef>
+                <a:spcPts val="0"/>
+              </a:spcBef>
+              <a:spcAft>
+                <a:spcPts val="0"/>
+              </a:spcAft>
+              <a:buSzPts val="2400"/>
+              <a:buNone/>
+            </a:pPr>
+            <a:endParaRPr lang="en-US" sz="1400" dirty="0">
+              <a:latin typeface="Courier New" panose="02070309020205020404" pitchFamily="49" charset="0"/>
+              <a:cs typeface="Courier New" panose="02070309020205020404" pitchFamily="49" charset="0"/>
+            </a:endParaRPr>
+          </a:p>
+          <a:p>
+            <a:pPr marL="0" indent="0">
+              <a:spcBef>
+                <a:spcPts val="0"/>
+              </a:spcBef>
+              <a:spcAft>
+                <a:spcPts val="0"/>
+              </a:spcAft>
+              <a:buSzPts val="2400"/>
+              <a:buNone/>
+            </a:pPr>
+            <a:r>
+              <a:rPr lang="en-US" sz="1400" dirty="0">
+                <a:latin typeface="Courier New" panose="02070309020205020404" pitchFamily="49" charset="0"/>
+                <a:cs typeface="Courier New" panose="02070309020205020404" pitchFamily="49" charset="0"/>
+              </a:rPr>
+              <a:t># Overview</a:t>
+            </a:r>
+          </a:p>
+          <a:p>
+            <a:pPr marL="0" indent="0">
+              <a:buNone/>
+            </a:pPr>
+            <a:r>
+              <a:rPr lang="en-US" sz="1400" dirty="0">
+                <a:latin typeface="Courier New" panose="02070309020205020404" pitchFamily="49" charset="0"/>
+                <a:cs typeface="Courier New" panose="02070309020205020404" pitchFamily="49" charset="0"/>
+              </a:rPr>
+              <a:t>This report is about </a:t>
+            </a:r>
+            <a:r>
+              <a:rPr lang="en-US" sz="1400" b="1" dirty="0">
+                <a:latin typeface="Courier New" panose="02070309020205020404" pitchFamily="49" charset="0"/>
+                <a:cs typeface="Courier New" panose="02070309020205020404" pitchFamily="49" charset="0"/>
+              </a:rPr>
+              <a:t>{{&lt; meta </a:t>
+            </a:r>
+            <a:r>
+              <a:rPr lang="en-US" sz="1400" b="1" dirty="0" err="1">
+                <a:latin typeface="Courier New" panose="02070309020205020404" pitchFamily="49" charset="0"/>
+                <a:cs typeface="Courier New" panose="02070309020205020404" pitchFamily="49" charset="0"/>
+              </a:rPr>
+              <a:t>params.species</a:t>
+            </a:r>
+            <a:r>
+              <a:rPr lang="en-US" sz="1400" b="1" dirty="0">
+                <a:latin typeface="Courier New" panose="02070309020205020404" pitchFamily="49" charset="0"/>
+                <a:cs typeface="Courier New" panose="02070309020205020404" pitchFamily="49" charset="0"/>
+              </a:rPr>
+              <a:t> &gt;}} {{&lt; meta </a:t>
+            </a:r>
+            <a:r>
+              <a:rPr lang="en-US" sz="1400" b="1" dirty="0" err="1">
+                <a:latin typeface="Courier New" panose="02070309020205020404" pitchFamily="49" charset="0"/>
+                <a:cs typeface="Courier New" panose="02070309020205020404" pitchFamily="49" charset="0"/>
+              </a:rPr>
+              <a:t>params.subtype</a:t>
+            </a:r>
+            <a:r>
+              <a:rPr lang="en-US" sz="1400" b="1" dirty="0">
+                <a:latin typeface="Courier New" panose="02070309020205020404" pitchFamily="49" charset="0"/>
+                <a:cs typeface="Courier New" panose="02070309020205020404" pitchFamily="49" charset="0"/>
+              </a:rPr>
+              <a:t> &gt;}} </a:t>
+            </a:r>
+            <a:r>
+              <a:rPr lang="en-US" sz="1400" dirty="0">
+                <a:latin typeface="Courier New" panose="02070309020205020404" pitchFamily="49" charset="0"/>
+                <a:cs typeface="Courier New" panose="02070309020205020404" pitchFamily="49" charset="0"/>
+              </a:rPr>
+              <a:t>...</a:t>
+            </a:r>
+          </a:p>
+          <a:p>
+            <a:endParaRPr lang="en-US" sz="1400" dirty="0">
+              <a:latin typeface="Courier New" panose="02070309020205020404" pitchFamily="49" charset="0"/>
+              <a:cs typeface="Courier New" panose="02070309020205020404" pitchFamily="49" charset="0"/>
+            </a:endParaRPr>
+          </a:p>
+          <a:p>
+            <a:pPr marL="0" indent="0">
+              <a:spcBef>
+                <a:spcPts val="0"/>
+              </a:spcBef>
+              <a:spcAft>
+                <a:spcPts val="0"/>
+              </a:spcAft>
+              <a:buSzPts val="2400"/>
+              <a:buNone/>
+            </a:pPr>
+            <a:endParaRPr lang="en-US" sz="1400" dirty="0">
+              <a:latin typeface="Courier New" panose="02070309020205020404" pitchFamily="49" charset="0"/>
+              <a:cs typeface="Courier New" panose="02070309020205020404" pitchFamily="49" charset="0"/>
+            </a:endParaRPr>
+          </a:p>
+        </p:txBody>
+      </p:sp>
+    </p:spTree>
+    <p:extLst>
+      <p:ext uri="{BB962C8B-B14F-4D97-AF65-F5344CB8AC3E}">
+        <p14:creationId xmlns:p14="http://schemas.microsoft.com/office/powerpoint/2010/main" val="768520439"/>
+      </p:ext>
+    </p:extLst>
+  </p:cSld>
+  <p:clrMapOvr>
+    <a:masterClrMapping/>
+  </p:clrMapOvr>
+</p:sld>
+</file>
+
+<file path=ppt/slides/slide19.xml><?xml version="1.0" encoding="utf-8"?>
+<p:sld xmlns:a="http://schemas.openxmlformats.org/drawingml/2006/main" xmlns:r="http://schemas.openxmlformats.org/officeDocument/2006/relationships" xmlns:p="http://schemas.openxmlformats.org/presentationml/2006/main">
+  <p:cSld>
+    <p:spTree>
+      <p:nvGrpSpPr>
+        <p:cNvPr id="1" name="">
+          <a:extLst>
+            <a:ext uri="{FF2B5EF4-FFF2-40B4-BE49-F238E27FC236}">
               <a16:creationId xmlns:a16="http://schemas.microsoft.com/office/drawing/2014/main" id="{035A638C-E200-83CC-7B12-711CAAE241CE}"/>
             </a:ext>
           </a:extLst>
@@ -26270,7 +28391,207 @@
 </p:sld>
 </file>
 
-<file path=ppt/slides/slide19.xml><?xml version="1.0" encoding="utf-8"?>
+<file path=ppt/slides/slide2.xml><?xml version="1.0" encoding="utf-8"?>
+<p:sld xmlns:a="http://schemas.openxmlformats.org/drawingml/2006/main" xmlns:r="http://schemas.openxmlformats.org/officeDocument/2006/relationships" xmlns:p="http://schemas.openxmlformats.org/presentationml/2006/main">
+  <p:cSld>
+    <p:spTree>
+      <p:nvGrpSpPr>
+        <p:cNvPr id="1" name="Shape 173"/>
+        <p:cNvGrpSpPr/>
+        <p:nvPr/>
+      </p:nvGrpSpPr>
+      <p:grpSpPr>
+        <a:xfrm>
+          <a:off x="0" y="0"/>
+          <a:ext cx="0" cy="0"/>
+          <a:chOff x="0" y="0"/>
+          <a:chExt cx="0" cy="0"/>
+        </a:xfrm>
+      </p:grpSpPr>
+      <p:sp>
+        <p:nvSpPr>
+          <p:cNvPr id="174" name="Google Shape;174;p24"/>
+          <p:cNvSpPr txBox="1">
+            <a:spLocks noGrp="1"/>
+          </p:cNvSpPr>
+          <p:nvPr>
+            <p:ph type="title"/>
+          </p:nvPr>
+        </p:nvSpPr>
+        <p:spPr>
+          <a:xfrm>
+            <a:off x="695326" y="136526"/>
+            <a:ext cx="10801351" cy="854075"/>
+          </a:xfrm>
+          <a:prstGeom prst="rect">
+            <a:avLst/>
+          </a:prstGeom>
+          <a:noFill/>
+          <a:ln>
+            <a:noFill/>
+          </a:ln>
+        </p:spPr>
+        <p:txBody>
+          <a:bodyPr spcFirstLastPara="1" wrap="square" lIns="91425" tIns="45700" rIns="91425" bIns="45700" anchor="t" anchorCtr="0">
+            <a:normAutofit/>
+          </a:bodyPr>
+          <a:lstStyle/>
+          <a:p>
+            <a:pPr marL="0" lvl="0" indent="0" algn="l" rtl="0">
+              <a:lnSpc>
+                <a:spcPct val="90000"/>
+              </a:lnSpc>
+              <a:spcBef>
+                <a:spcPts val="0"/>
+              </a:spcBef>
+              <a:spcAft>
+                <a:spcPts val="0"/>
+              </a:spcAft>
+              <a:buClr>
+                <a:srgbClr val="007783"/>
+              </a:buClr>
+              <a:buSzPts val="3600"/>
+              <a:buFont typeface="Libre Franklin Medium"/>
+              <a:buNone/>
+            </a:pPr>
+            <a:r>
+              <a:rPr lang="en-US" dirty="0"/>
+              <a:t>Funding Disclosure</a:t>
+            </a:r>
+            <a:endParaRPr dirty="0"/>
+          </a:p>
+        </p:txBody>
+      </p:sp>
+      <p:sp>
+        <p:nvSpPr>
+          <p:cNvPr id="175" name="Google Shape;175;p24"/>
+          <p:cNvSpPr txBox="1">
+            <a:spLocks noGrp="1"/>
+          </p:cNvSpPr>
+          <p:nvPr>
+            <p:ph type="body" idx="1"/>
+          </p:nvPr>
+        </p:nvSpPr>
+        <p:spPr>
+          <a:xfrm>
+            <a:off x="695326" y="1169986"/>
+            <a:ext cx="10801351" cy="5067302"/>
+          </a:xfrm>
+          <a:prstGeom prst="rect">
+            <a:avLst/>
+          </a:prstGeom>
+          <a:noFill/>
+          <a:ln>
+            <a:noFill/>
+          </a:ln>
+        </p:spPr>
+        <p:txBody>
+          <a:bodyPr spcFirstLastPara="1" wrap="square" lIns="91425" tIns="45700" rIns="91425" bIns="45700" anchor="t" anchorCtr="0">
+            <a:noAutofit/>
+          </a:bodyPr>
+          <a:lstStyle/>
+          <a:p>
+            <a:pPr marL="227965" lvl="0" indent="-227965" algn="l" rtl="0">
+              <a:lnSpc>
+                <a:spcPct val="110000"/>
+              </a:lnSpc>
+              <a:spcBef>
+                <a:spcPts val="0"/>
+              </a:spcBef>
+              <a:spcAft>
+                <a:spcPts val="0"/>
+              </a:spcAft>
+              <a:buSzPts val="2400"/>
+              <a:buChar char="•"/>
+            </a:pPr>
+            <a:r>
+              <a:rPr lang="en-US" dirty="0"/>
+              <a:t>This work is supported by the United States Centers for Disease Control and Prevention funding under the Global Health Security Partnerships: Expanding and Improving Public Health Laboratory Strategies and Systems (Grant Number: NU2HGH000080).</a:t>
+            </a:r>
+            <a:endParaRPr dirty="0"/>
+          </a:p>
+        </p:txBody>
+      </p:sp>
+      <p:sp>
+        <p:nvSpPr>
+          <p:cNvPr id="176" name="Google Shape;176;p24"/>
+          <p:cNvSpPr txBox="1">
+            <a:spLocks noGrp="1"/>
+          </p:cNvSpPr>
+          <p:nvPr>
+            <p:ph type="sldNum" idx="12"/>
+          </p:nvPr>
+        </p:nvSpPr>
+        <p:spPr>
+          <a:xfrm>
+            <a:off x="11496674" y="6418264"/>
+            <a:ext cx="695327" cy="365125"/>
+          </a:xfrm>
+          <a:prstGeom prst="rect">
+            <a:avLst/>
+          </a:prstGeom>
+          <a:noFill/>
+          <a:ln>
+            <a:noFill/>
+          </a:ln>
+        </p:spPr>
+        <p:txBody>
+          <a:bodyPr spcFirstLastPara="1" wrap="square" lIns="91425" tIns="45700" rIns="91425" bIns="45700" anchor="ctr" anchorCtr="0">
+            <a:noAutofit/>
+          </a:bodyPr>
+          <a:lstStyle/>
+          <a:p>
+            <a:pPr marL="0" lvl="0" indent="0" algn="ctr" rtl="0">
+              <a:spcBef>
+                <a:spcPts val="0"/>
+              </a:spcBef>
+              <a:spcAft>
+                <a:spcPts val="0"/>
+              </a:spcAft>
+              <a:buNone/>
+            </a:pPr>
+            <a:fld id="{00000000-1234-1234-1234-123412341234}" type="slidenum">
+              <a:rPr lang="en-US"/>
+              <a:t>2</a:t>
+            </a:fld>
+            <a:endParaRPr/>
+          </a:p>
+        </p:txBody>
+      </p:sp>
+      <p:sp>
+        <p:nvSpPr>
+          <p:cNvPr id="2" name="Footer Placeholder 1">
+            <a:extLst>
+              <a:ext uri="{FF2B5EF4-FFF2-40B4-BE49-F238E27FC236}">
+                <a16:creationId xmlns:a16="http://schemas.microsoft.com/office/drawing/2014/main" id="{A7A15C4C-81DB-21CC-0922-E0EC1B2B64E5}"/>
+              </a:ext>
+            </a:extLst>
+          </p:cNvPr>
+          <p:cNvSpPr>
+            <a:spLocks noGrp="1"/>
+          </p:cNvSpPr>
+          <p:nvPr>
+            <p:ph type="ftr" sz="quarter" idx="11"/>
+          </p:nvPr>
+        </p:nvSpPr>
+        <p:spPr/>
+        <p:txBody>
+          <a:bodyPr/>
+          <a:lstStyle/>
+          <a:p>
+            <a:endParaRPr lang="en-US" dirty="0"/>
+          </a:p>
+        </p:txBody>
+      </p:sp>
+    </p:spTree>
+  </p:cSld>
+  <p:clrMapOvr>
+    <a:masterClrMapping/>
+  </p:clrMapOvr>
+</p:sld>
+</file>
+
+<file path=ppt/slides/slide20.xml><?xml version="1.0" encoding="utf-8"?>
 <p:sld xmlns:a="http://schemas.openxmlformats.org/drawingml/2006/main" xmlns:r="http://schemas.openxmlformats.org/officeDocument/2006/relationships" xmlns:p="http://schemas.openxmlformats.org/presentationml/2006/main">
   <p:cSld>
     <p:spTree>
@@ -26381,7 +28702,7 @@
             <a:fld id="{FFA67747-A1D0-4850-AF9A-570B1A0E3F7F}" type="slidenum">
               <a:rPr lang="en-US" smtClean="0"/>
               <a:pPr/>
-              <a:t>19</a:t>
+              <a:t>20</a:t>
             </a:fld>
             <a:endParaRPr lang="en-US" dirty="0"/>
           </a:p>
@@ -27004,207 +29325,7 @@
 </p:sld>
 </file>
 
-<file path=ppt/slides/slide2.xml><?xml version="1.0" encoding="utf-8"?>
-<p:sld xmlns:a="http://schemas.openxmlformats.org/drawingml/2006/main" xmlns:r="http://schemas.openxmlformats.org/officeDocument/2006/relationships" xmlns:p="http://schemas.openxmlformats.org/presentationml/2006/main">
-  <p:cSld>
-    <p:spTree>
-      <p:nvGrpSpPr>
-        <p:cNvPr id="1" name="Shape 173"/>
-        <p:cNvGrpSpPr/>
-        <p:nvPr/>
-      </p:nvGrpSpPr>
-      <p:grpSpPr>
-        <a:xfrm>
-          <a:off x="0" y="0"/>
-          <a:ext cx="0" cy="0"/>
-          <a:chOff x="0" y="0"/>
-          <a:chExt cx="0" cy="0"/>
-        </a:xfrm>
-      </p:grpSpPr>
-      <p:sp>
-        <p:nvSpPr>
-          <p:cNvPr id="174" name="Google Shape;174;p24"/>
-          <p:cNvSpPr txBox="1">
-            <a:spLocks noGrp="1"/>
-          </p:cNvSpPr>
-          <p:nvPr>
-            <p:ph type="title"/>
-          </p:nvPr>
-        </p:nvSpPr>
-        <p:spPr>
-          <a:xfrm>
-            <a:off x="695326" y="136526"/>
-            <a:ext cx="10801351" cy="854075"/>
-          </a:xfrm>
-          <a:prstGeom prst="rect">
-            <a:avLst/>
-          </a:prstGeom>
-          <a:noFill/>
-          <a:ln>
-            <a:noFill/>
-          </a:ln>
-        </p:spPr>
-        <p:txBody>
-          <a:bodyPr spcFirstLastPara="1" wrap="square" lIns="91425" tIns="45700" rIns="91425" bIns="45700" anchor="t" anchorCtr="0">
-            <a:normAutofit/>
-          </a:bodyPr>
-          <a:lstStyle/>
-          <a:p>
-            <a:pPr marL="0" lvl="0" indent="0" algn="l" rtl="0">
-              <a:lnSpc>
-                <a:spcPct val="90000"/>
-              </a:lnSpc>
-              <a:spcBef>
-                <a:spcPts val="0"/>
-              </a:spcBef>
-              <a:spcAft>
-                <a:spcPts val="0"/>
-              </a:spcAft>
-              <a:buClr>
-                <a:srgbClr val="007783"/>
-              </a:buClr>
-              <a:buSzPts val="3600"/>
-              <a:buFont typeface="Libre Franklin Medium"/>
-              <a:buNone/>
-            </a:pPr>
-            <a:r>
-              <a:rPr lang="en-US" dirty="0"/>
-              <a:t>Funding Disclosure</a:t>
-            </a:r>
-            <a:endParaRPr dirty="0"/>
-          </a:p>
-        </p:txBody>
-      </p:sp>
-      <p:sp>
-        <p:nvSpPr>
-          <p:cNvPr id="175" name="Google Shape;175;p24"/>
-          <p:cNvSpPr txBox="1">
-            <a:spLocks noGrp="1"/>
-          </p:cNvSpPr>
-          <p:nvPr>
-            <p:ph type="body" idx="1"/>
-          </p:nvPr>
-        </p:nvSpPr>
-        <p:spPr>
-          <a:xfrm>
-            <a:off x="695326" y="1169986"/>
-            <a:ext cx="10801351" cy="5067302"/>
-          </a:xfrm>
-          <a:prstGeom prst="rect">
-            <a:avLst/>
-          </a:prstGeom>
-          <a:noFill/>
-          <a:ln>
-            <a:noFill/>
-          </a:ln>
-        </p:spPr>
-        <p:txBody>
-          <a:bodyPr spcFirstLastPara="1" wrap="square" lIns="91425" tIns="45700" rIns="91425" bIns="45700" anchor="t" anchorCtr="0">
-            <a:noAutofit/>
-          </a:bodyPr>
-          <a:lstStyle/>
-          <a:p>
-            <a:pPr marL="227965" lvl="0" indent="-227965" algn="l" rtl="0">
-              <a:lnSpc>
-                <a:spcPct val="110000"/>
-              </a:lnSpc>
-              <a:spcBef>
-                <a:spcPts val="0"/>
-              </a:spcBef>
-              <a:spcAft>
-                <a:spcPts val="0"/>
-              </a:spcAft>
-              <a:buSzPts val="2400"/>
-              <a:buChar char="•"/>
-            </a:pPr>
-            <a:r>
-              <a:rPr lang="en-US" dirty="0"/>
-              <a:t>This work is supported by the United States Centers for Disease Control and Prevention funding under the Global Health Security Partnerships: Expanding and Improving Public Health Laboratory Strategies and Systems (Grant Number: NU2HGH000080).</a:t>
-            </a:r>
-            <a:endParaRPr dirty="0"/>
-          </a:p>
-        </p:txBody>
-      </p:sp>
-      <p:sp>
-        <p:nvSpPr>
-          <p:cNvPr id="176" name="Google Shape;176;p24"/>
-          <p:cNvSpPr txBox="1">
-            <a:spLocks noGrp="1"/>
-          </p:cNvSpPr>
-          <p:nvPr>
-            <p:ph type="sldNum" idx="12"/>
-          </p:nvPr>
-        </p:nvSpPr>
-        <p:spPr>
-          <a:xfrm>
-            <a:off x="11496674" y="6418264"/>
-            <a:ext cx="695327" cy="365125"/>
-          </a:xfrm>
-          <a:prstGeom prst="rect">
-            <a:avLst/>
-          </a:prstGeom>
-          <a:noFill/>
-          <a:ln>
-            <a:noFill/>
-          </a:ln>
-        </p:spPr>
-        <p:txBody>
-          <a:bodyPr spcFirstLastPara="1" wrap="square" lIns="91425" tIns="45700" rIns="91425" bIns="45700" anchor="ctr" anchorCtr="0">
-            <a:noAutofit/>
-          </a:bodyPr>
-          <a:lstStyle/>
-          <a:p>
-            <a:pPr marL="0" lvl="0" indent="0" algn="ctr" rtl="0">
-              <a:spcBef>
-                <a:spcPts val="0"/>
-              </a:spcBef>
-              <a:spcAft>
-                <a:spcPts val="0"/>
-              </a:spcAft>
-              <a:buNone/>
-            </a:pPr>
-            <a:fld id="{00000000-1234-1234-1234-123412341234}" type="slidenum">
-              <a:rPr lang="en-US"/>
-              <a:t>2</a:t>
-            </a:fld>
-            <a:endParaRPr/>
-          </a:p>
-        </p:txBody>
-      </p:sp>
-      <p:sp>
-        <p:nvSpPr>
-          <p:cNvPr id="2" name="Footer Placeholder 1">
-            <a:extLst>
-              <a:ext uri="{FF2B5EF4-FFF2-40B4-BE49-F238E27FC236}">
-                <a16:creationId xmlns:a16="http://schemas.microsoft.com/office/drawing/2014/main" id="{A7A15C4C-81DB-21CC-0922-E0EC1B2B64E5}"/>
-              </a:ext>
-            </a:extLst>
-          </p:cNvPr>
-          <p:cNvSpPr>
-            <a:spLocks noGrp="1"/>
-          </p:cNvSpPr>
-          <p:nvPr>
-            <p:ph type="ftr" sz="quarter" idx="11"/>
-          </p:nvPr>
-        </p:nvSpPr>
-        <p:spPr/>
-        <p:txBody>
-          <a:bodyPr/>
-          <a:lstStyle/>
-          <a:p>
-            <a:endParaRPr lang="en-US" dirty="0"/>
-          </a:p>
-        </p:txBody>
-      </p:sp>
-    </p:spTree>
-  </p:cSld>
-  <p:clrMapOvr>
-    <a:masterClrMapping/>
-  </p:clrMapOvr>
-</p:sld>
-</file>
-
-<file path=ppt/slides/slide20.xml><?xml version="1.0" encoding="utf-8"?>
+<file path=ppt/slides/slide21.xml><?xml version="1.0" encoding="utf-8"?>
 <p:sld xmlns:a="http://schemas.openxmlformats.org/drawingml/2006/main" xmlns:r="http://schemas.openxmlformats.org/officeDocument/2006/relationships" xmlns:p="http://schemas.openxmlformats.org/presentationml/2006/main">
   <p:cSld>
     <p:spTree>
@@ -27315,7 +29436,7 @@
             <a:fld id="{FFA67747-A1D0-4850-AF9A-570B1A0E3F7F}" type="slidenum">
               <a:rPr lang="en-US" smtClean="0"/>
               <a:pPr/>
-              <a:t>20</a:t>
+              <a:t>21</a:t>
             </a:fld>
             <a:endParaRPr lang="en-US" dirty="0"/>
           </a:p>
@@ -29383,7 +31504,1536 @@
 </p:sld>
 </file>
 
-<file path=ppt/slides/slide21.xml><?xml version="1.0" encoding="utf-8"?>
+<file path=ppt/slides/slide22.xml><?xml version="1.0" encoding="utf-8"?>
+<p:sld xmlns:a="http://schemas.openxmlformats.org/drawingml/2006/main" xmlns:r="http://schemas.openxmlformats.org/officeDocument/2006/relationships" xmlns:p="http://schemas.openxmlformats.org/presentationml/2006/main">
+  <p:cSld>
+    <p:spTree>
+      <p:nvGrpSpPr>
+        <p:cNvPr id="1" name="">
+          <a:extLst>
+            <a:ext uri="{FF2B5EF4-FFF2-40B4-BE49-F238E27FC236}">
+              <a16:creationId xmlns:a16="http://schemas.microsoft.com/office/drawing/2014/main" id="{D38C2B50-C9E7-772B-F87A-0EC21730ABA6}"/>
+            </a:ext>
+          </a:extLst>
+        </p:cNvPr>
+        <p:cNvGrpSpPr/>
+        <p:nvPr/>
+      </p:nvGrpSpPr>
+      <p:grpSpPr>
+        <a:xfrm>
+          <a:off x="0" y="0"/>
+          <a:ext cx="0" cy="0"/>
+          <a:chOff x="0" y="0"/>
+          <a:chExt cx="0" cy="0"/>
+        </a:xfrm>
+      </p:grpSpPr>
+      <p:sp>
+        <p:nvSpPr>
+          <p:cNvPr id="46" name="Round Same Side Corner Rectangle 45">
+            <a:extLst>
+              <a:ext uri="{FF2B5EF4-FFF2-40B4-BE49-F238E27FC236}">
+                <a16:creationId xmlns:a16="http://schemas.microsoft.com/office/drawing/2014/main" id="{E536D6F4-312F-0572-5DEB-89F0143ABC80}"/>
+              </a:ext>
+            </a:extLst>
+          </p:cNvPr>
+          <p:cNvSpPr/>
+          <p:nvPr/>
+        </p:nvSpPr>
+        <p:spPr>
+          <a:xfrm>
+            <a:off x="5437940" y="5004308"/>
+            <a:ext cx="6058737" cy="1203817"/>
+          </a:xfrm>
+          <a:prstGeom prst="round2SameRect">
+            <a:avLst/>
+          </a:prstGeom>
+          <a:solidFill>
+            <a:schemeClr val="bg1">
+              <a:lumMod val="85000"/>
+            </a:schemeClr>
+          </a:solidFill>
+          <a:ln>
+            <a:noFill/>
+          </a:ln>
+        </p:spPr>
+        <p:style>
+          <a:lnRef idx="2">
+            <a:schemeClr val="accent1">
+              <a:shade val="50000"/>
+            </a:schemeClr>
+          </a:lnRef>
+          <a:fillRef idx="1">
+            <a:schemeClr val="accent1"/>
+          </a:fillRef>
+          <a:effectRef idx="0">
+            <a:schemeClr val="accent1"/>
+          </a:effectRef>
+          <a:fontRef idx="minor">
+            <a:schemeClr val="lt1"/>
+          </a:fontRef>
+        </p:style>
+        <p:txBody>
+          <a:bodyPr tIns="72000" bIns="72000" rtlCol="0" anchor="ctr"/>
+          <a:lstStyle/>
+          <a:p>
+            <a:pPr algn="ctr">
+              <a:spcAft>
+                <a:spcPts val="600"/>
+              </a:spcAft>
+            </a:pPr>
+            <a:endParaRPr lang="en-US" dirty="0"/>
+          </a:p>
+        </p:txBody>
+      </p:sp>
+      <p:sp>
+        <p:nvSpPr>
+          <p:cNvPr id="45" name="Rounded Rectangle 44">
+            <a:extLst>
+              <a:ext uri="{FF2B5EF4-FFF2-40B4-BE49-F238E27FC236}">
+                <a16:creationId xmlns:a16="http://schemas.microsoft.com/office/drawing/2014/main" id="{9794448F-6014-0A1E-2803-B3D38DD0DA31}"/>
+              </a:ext>
+            </a:extLst>
+          </p:cNvPr>
+          <p:cNvSpPr/>
+          <p:nvPr/>
+        </p:nvSpPr>
+        <p:spPr>
+          <a:xfrm>
+            <a:off x="5626849" y="5339933"/>
+            <a:ext cx="5680918" cy="582261"/>
+          </a:xfrm>
+          <a:prstGeom prst="roundRect">
+            <a:avLst/>
+          </a:prstGeom>
+          <a:solidFill>
+            <a:schemeClr val="bg1">
+              <a:lumMod val="95000"/>
+            </a:schemeClr>
+          </a:solidFill>
+          <a:ln>
+            <a:noFill/>
+          </a:ln>
+        </p:spPr>
+        <p:style>
+          <a:lnRef idx="2">
+            <a:schemeClr val="accent1">
+              <a:shade val="50000"/>
+            </a:schemeClr>
+          </a:lnRef>
+          <a:fillRef idx="1">
+            <a:schemeClr val="accent1"/>
+          </a:fillRef>
+          <a:effectRef idx="0">
+            <a:schemeClr val="accent1"/>
+          </a:effectRef>
+          <a:fontRef idx="minor">
+            <a:schemeClr val="lt1"/>
+          </a:fontRef>
+        </p:style>
+        <p:txBody>
+          <a:bodyPr tIns="72000" bIns="72000" rtlCol="0" anchor="ctr"/>
+          <a:lstStyle/>
+          <a:p>
+            <a:pPr algn="ctr">
+              <a:spcAft>
+                <a:spcPts val="600"/>
+              </a:spcAft>
+            </a:pPr>
+            <a:endParaRPr lang="en-US" dirty="0"/>
+          </a:p>
+        </p:txBody>
+      </p:sp>
+      <p:sp>
+        <p:nvSpPr>
+          <p:cNvPr id="10" name="Title 9">
+            <a:extLst>
+              <a:ext uri="{FF2B5EF4-FFF2-40B4-BE49-F238E27FC236}">
+                <a16:creationId xmlns:a16="http://schemas.microsoft.com/office/drawing/2014/main" id="{46229E59-E904-FDE6-68A6-94F47CCB4BDF}"/>
+              </a:ext>
+            </a:extLst>
+          </p:cNvPr>
+          <p:cNvSpPr>
+            <a:spLocks noGrp="1"/>
+          </p:cNvSpPr>
+          <p:nvPr>
+            <p:ph type="title"/>
+          </p:nvPr>
+        </p:nvSpPr>
+        <p:spPr/>
+        <p:txBody>
+          <a:bodyPr/>
+          <a:lstStyle/>
+          <a:p>
+            <a:r>
+              <a:rPr lang="en-US" dirty="0"/>
+              <a:t>Sharing Quarto reports</a:t>
+            </a:r>
+          </a:p>
+        </p:txBody>
+      </p:sp>
+      <p:sp>
+        <p:nvSpPr>
+          <p:cNvPr id="11" name="Rounded Rectangle 10">
+            <a:extLst>
+              <a:ext uri="{FF2B5EF4-FFF2-40B4-BE49-F238E27FC236}">
+                <a16:creationId xmlns:a16="http://schemas.microsoft.com/office/drawing/2014/main" id="{21FD762C-4EBB-70BE-2BE2-805CA95F8FA2}"/>
+              </a:ext>
+            </a:extLst>
+          </p:cNvPr>
+          <p:cNvSpPr/>
+          <p:nvPr/>
+        </p:nvSpPr>
+        <p:spPr>
+          <a:xfrm>
+            <a:off x="1155184" y="1616934"/>
+            <a:ext cx="6643945" cy="1835773"/>
+          </a:xfrm>
+          <a:prstGeom prst="roundRect">
+            <a:avLst>
+              <a:gd name="adj" fmla="val 5855"/>
+            </a:avLst>
+          </a:prstGeom>
+          <a:solidFill>
+            <a:schemeClr val="bg1">
+              <a:lumMod val="95000"/>
+            </a:schemeClr>
+          </a:solidFill>
+          <a:ln>
+            <a:noFill/>
+          </a:ln>
+        </p:spPr>
+        <p:style>
+          <a:lnRef idx="2">
+            <a:schemeClr val="accent1">
+              <a:shade val="50000"/>
+            </a:schemeClr>
+          </a:lnRef>
+          <a:fillRef idx="1">
+            <a:schemeClr val="accent1"/>
+          </a:fillRef>
+          <a:effectRef idx="0">
+            <a:schemeClr val="accent1"/>
+          </a:effectRef>
+          <a:fontRef idx="minor">
+            <a:schemeClr val="lt1"/>
+          </a:fontRef>
+        </p:style>
+        <p:txBody>
+          <a:bodyPr tIns="72000" bIns="72000" rtlCol="0" anchor="ctr"/>
+          <a:lstStyle/>
+          <a:p>
+            <a:pPr algn="ctr">
+              <a:spcAft>
+                <a:spcPts val="600"/>
+              </a:spcAft>
+            </a:pPr>
+            <a:endParaRPr lang="en-US" sz="2400" dirty="0"/>
+          </a:p>
+        </p:txBody>
+      </p:sp>
+      <p:sp>
+        <p:nvSpPr>
+          <p:cNvPr id="12" name="Google Shape;175;p24">
+            <a:extLst>
+              <a:ext uri="{FF2B5EF4-FFF2-40B4-BE49-F238E27FC236}">
+                <a16:creationId xmlns:a16="http://schemas.microsoft.com/office/drawing/2014/main" id="{FF08FF28-A686-A77A-6EC9-26ADDABC1204}"/>
+              </a:ext>
+            </a:extLst>
+          </p:cNvPr>
+          <p:cNvSpPr txBox="1">
+            <a:spLocks/>
+          </p:cNvSpPr>
+          <p:nvPr/>
+        </p:nvSpPr>
+        <p:spPr>
+          <a:xfrm>
+            <a:off x="1262450" y="1808712"/>
+            <a:ext cx="6297326" cy="1643995"/>
+          </a:xfrm>
+          <a:prstGeom prst="rect">
+            <a:avLst/>
+          </a:prstGeom>
+          <a:noFill/>
+          <a:ln>
+            <a:noFill/>
+          </a:ln>
+        </p:spPr>
+        <p:txBody>
+          <a:bodyPr spcFirstLastPara="1" vert="horz" wrap="square" lIns="91425" tIns="45700" rIns="91425" bIns="45700" rtlCol="0" anchor="t" anchorCtr="0">
+            <a:noAutofit/>
+          </a:bodyPr>
+          <a:lstStyle>
+            <a:lvl1pPr marL="228594" indent="-228594" algn="l" defTabSz="914377" rtl="0" eaLnBrk="1" latinLnBrk="0" hangingPunct="1">
+              <a:lnSpc>
+                <a:spcPct val="110000"/>
+              </a:lnSpc>
+              <a:spcBef>
+                <a:spcPts val="1000"/>
+              </a:spcBef>
+              <a:spcAft>
+                <a:spcPts val="600"/>
+              </a:spcAft>
+              <a:buClrTx/>
+              <a:buFont typeface="Arial" panose="020B0604020202020204" pitchFamily="34" charset="0"/>
+              <a:buChar char="•"/>
+              <a:defRPr sz="2400" kern="1200">
+                <a:solidFill>
+                  <a:schemeClr val="tx1"/>
+                </a:solidFill>
+                <a:latin typeface="Arial" panose="020B0604020202020204" pitchFamily="34" charset="0"/>
+                <a:ea typeface="+mn-ea"/>
+                <a:cs typeface="Arial" panose="020B0604020202020204" pitchFamily="34" charset="0"/>
+              </a:defRPr>
+            </a:lvl1pPr>
+            <a:lvl2pPr marL="542912" indent="-228594" algn="l" defTabSz="914377" rtl="0" eaLnBrk="1" latinLnBrk="0" hangingPunct="1">
+              <a:lnSpc>
+                <a:spcPct val="110000"/>
+              </a:lnSpc>
+              <a:spcBef>
+                <a:spcPts val="500"/>
+              </a:spcBef>
+              <a:spcAft>
+                <a:spcPts val="600"/>
+              </a:spcAft>
+              <a:buClrTx/>
+              <a:buFont typeface="Arial" panose="020B0604020202020204" pitchFamily="34" charset="0"/>
+              <a:buChar char="•"/>
+              <a:defRPr sz="2000" kern="1200">
+                <a:solidFill>
+                  <a:schemeClr val="tx1"/>
+                </a:solidFill>
+                <a:latin typeface="Arial" panose="020B0604020202020204" pitchFamily="34" charset="0"/>
+                <a:ea typeface="+mn-ea"/>
+                <a:cs typeface="Arial" panose="020B0604020202020204" pitchFamily="34" charset="0"/>
+              </a:defRPr>
+            </a:lvl2pPr>
+            <a:lvl3pPr marL="895328" indent="-228594" algn="l" defTabSz="914377" rtl="0" eaLnBrk="1" latinLnBrk="0" hangingPunct="1">
+              <a:lnSpc>
+                <a:spcPct val="110000"/>
+              </a:lnSpc>
+              <a:spcBef>
+                <a:spcPts val="500"/>
+              </a:spcBef>
+              <a:spcAft>
+                <a:spcPts val="600"/>
+              </a:spcAft>
+              <a:buClrTx/>
+              <a:buFont typeface="Arial" panose="020B0604020202020204" pitchFamily="34" charset="0"/>
+              <a:buChar char="•"/>
+              <a:defRPr sz="1800" kern="1200">
+                <a:solidFill>
+                  <a:schemeClr val="tx1"/>
+                </a:solidFill>
+                <a:latin typeface="Arial" panose="020B0604020202020204" pitchFamily="34" charset="0"/>
+                <a:ea typeface="+mn-ea"/>
+                <a:cs typeface="Arial" panose="020B0604020202020204" pitchFamily="34" charset="0"/>
+              </a:defRPr>
+            </a:lvl3pPr>
+            <a:lvl4pPr marL="1257269" indent="-228594" algn="l" defTabSz="914377" rtl="0" eaLnBrk="1" latinLnBrk="0" hangingPunct="1">
+              <a:lnSpc>
+                <a:spcPct val="110000"/>
+              </a:lnSpc>
+              <a:spcBef>
+                <a:spcPts val="500"/>
+              </a:spcBef>
+              <a:spcAft>
+                <a:spcPts val="600"/>
+              </a:spcAft>
+              <a:buClrTx/>
+              <a:buFont typeface="Arial" panose="020B0604020202020204" pitchFamily="34" charset="0"/>
+              <a:buChar char="•"/>
+              <a:defRPr sz="1600" kern="1200">
+                <a:solidFill>
+                  <a:schemeClr val="tx1"/>
+                </a:solidFill>
+                <a:latin typeface="Arial" panose="020B0604020202020204" pitchFamily="34" charset="0"/>
+                <a:ea typeface="+mn-ea"/>
+                <a:cs typeface="Arial" panose="020B0604020202020204" pitchFamily="34" charset="0"/>
+              </a:defRPr>
+            </a:lvl4pPr>
+            <a:lvl5pPr marL="1619210" indent="-228594" algn="l" defTabSz="914377" rtl="0" eaLnBrk="1" latinLnBrk="0" hangingPunct="1">
+              <a:lnSpc>
+                <a:spcPct val="110000"/>
+              </a:lnSpc>
+              <a:spcBef>
+                <a:spcPts val="500"/>
+              </a:spcBef>
+              <a:spcAft>
+                <a:spcPts val="600"/>
+              </a:spcAft>
+              <a:buClrTx/>
+              <a:buFont typeface="Arial" panose="020B0604020202020204" pitchFamily="34" charset="0"/>
+              <a:buChar char="•"/>
+              <a:tabLst>
+                <a:tab pos="1619210" algn="l"/>
+              </a:tabLst>
+              <a:defRPr sz="1600" kern="1200">
+                <a:solidFill>
+                  <a:schemeClr val="tx1"/>
+                </a:solidFill>
+                <a:latin typeface="Arial" panose="020B0604020202020204" pitchFamily="34" charset="0"/>
+                <a:ea typeface="+mn-ea"/>
+                <a:cs typeface="Arial" panose="020B0604020202020204" pitchFamily="34" charset="0"/>
+              </a:defRPr>
+            </a:lvl5pPr>
+            <a:lvl6pPr marL="2514537" indent="-228594" algn="l" defTabSz="914377" rtl="0" eaLnBrk="1" latinLnBrk="0" hangingPunct="1">
+              <a:lnSpc>
+                <a:spcPct val="90000"/>
+              </a:lnSpc>
+              <a:spcBef>
+                <a:spcPts val="500"/>
+              </a:spcBef>
+              <a:buFont typeface="Arial" panose="020B0604020202020204" pitchFamily="34" charset="0"/>
+              <a:buChar char="•"/>
+              <a:defRPr sz="1800" kern="1200">
+                <a:solidFill>
+                  <a:schemeClr val="tx1"/>
+                </a:solidFill>
+                <a:latin typeface="+mn-lt"/>
+                <a:ea typeface="+mn-ea"/>
+                <a:cs typeface="+mn-cs"/>
+              </a:defRPr>
+            </a:lvl6pPr>
+            <a:lvl7pPr marL="2971726" indent="-228594" algn="l" defTabSz="914377" rtl="0" eaLnBrk="1" latinLnBrk="0" hangingPunct="1">
+              <a:lnSpc>
+                <a:spcPct val="90000"/>
+              </a:lnSpc>
+              <a:spcBef>
+                <a:spcPts val="500"/>
+              </a:spcBef>
+              <a:buFont typeface="Arial" panose="020B0604020202020204" pitchFamily="34" charset="0"/>
+              <a:buChar char="•"/>
+              <a:defRPr sz="1800" kern="1200">
+                <a:solidFill>
+                  <a:schemeClr val="tx1"/>
+                </a:solidFill>
+                <a:latin typeface="+mn-lt"/>
+                <a:ea typeface="+mn-ea"/>
+                <a:cs typeface="+mn-cs"/>
+              </a:defRPr>
+            </a:lvl7pPr>
+            <a:lvl8pPr marL="3428914" indent="-228594" algn="l" defTabSz="914377" rtl="0" eaLnBrk="1" latinLnBrk="0" hangingPunct="1">
+              <a:lnSpc>
+                <a:spcPct val="90000"/>
+              </a:lnSpc>
+              <a:spcBef>
+                <a:spcPts val="500"/>
+              </a:spcBef>
+              <a:buFont typeface="Arial" panose="020B0604020202020204" pitchFamily="34" charset="0"/>
+              <a:buChar char="•"/>
+              <a:defRPr sz="1800" kern="1200">
+                <a:solidFill>
+                  <a:schemeClr val="tx1"/>
+                </a:solidFill>
+                <a:latin typeface="+mn-lt"/>
+                <a:ea typeface="+mn-ea"/>
+                <a:cs typeface="+mn-cs"/>
+              </a:defRPr>
+            </a:lvl8pPr>
+            <a:lvl9pPr marL="3886103" indent="-228594" algn="l" defTabSz="914377" rtl="0" eaLnBrk="1" latinLnBrk="0" hangingPunct="1">
+              <a:lnSpc>
+                <a:spcPct val="90000"/>
+              </a:lnSpc>
+              <a:spcBef>
+                <a:spcPts val="500"/>
+              </a:spcBef>
+              <a:buFont typeface="Arial" panose="020B0604020202020204" pitchFamily="34" charset="0"/>
+              <a:buChar char="•"/>
+              <a:defRPr sz="1800" kern="1200">
+                <a:solidFill>
+                  <a:schemeClr val="tx1"/>
+                </a:solidFill>
+                <a:latin typeface="+mn-lt"/>
+                <a:ea typeface="+mn-ea"/>
+                <a:cs typeface="+mn-cs"/>
+              </a:defRPr>
+            </a:lvl9pPr>
+          </a:lstStyle>
+          <a:p>
+            <a:pPr marL="0" indent="0">
+              <a:spcBef>
+                <a:spcPts val="0"/>
+              </a:spcBef>
+              <a:spcAft>
+                <a:spcPts val="0"/>
+              </a:spcAft>
+              <a:buSzPts val="2400"/>
+              <a:buNone/>
+            </a:pPr>
+            <a:r>
+              <a:rPr lang="en-US" sz="1800" dirty="0">
+                <a:latin typeface="Courier New" panose="02070309020205020404" pitchFamily="49" charset="0"/>
+                <a:cs typeface="Courier New" panose="02070309020205020404" pitchFamily="49" charset="0"/>
+              </a:rPr>
+              <a:t>---</a:t>
+            </a:r>
+          </a:p>
+          <a:p>
+            <a:pPr marL="0" indent="0">
+              <a:spcBef>
+                <a:spcPts val="0"/>
+              </a:spcBef>
+              <a:spcAft>
+                <a:spcPts val="0"/>
+              </a:spcAft>
+              <a:buSzPts val="2400"/>
+              <a:buNone/>
+            </a:pPr>
+            <a:r>
+              <a:rPr lang="en-US" sz="1800" dirty="0">
+                <a:latin typeface="Courier New" panose="02070309020205020404" pitchFamily="49" charset="0"/>
+                <a:cs typeface="Courier New" panose="02070309020205020404" pitchFamily="49" charset="0"/>
+              </a:rPr>
+              <a:t>format:</a:t>
+            </a:r>
+          </a:p>
+          <a:p>
+            <a:pPr marL="0" indent="0">
+              <a:spcBef>
+                <a:spcPts val="0"/>
+              </a:spcBef>
+              <a:spcAft>
+                <a:spcPts val="0"/>
+              </a:spcAft>
+              <a:buSzPts val="2400"/>
+              <a:buNone/>
+            </a:pPr>
+            <a:r>
+              <a:rPr lang="en-US" sz="1800" dirty="0">
+                <a:latin typeface="Courier New" panose="02070309020205020404" pitchFamily="49" charset="0"/>
+                <a:cs typeface="Courier New" panose="02070309020205020404" pitchFamily="49" charset="0"/>
+              </a:rPr>
+              <a:t>  html:</a:t>
+            </a:r>
+          </a:p>
+          <a:p>
+            <a:pPr marL="0" indent="0">
+              <a:spcBef>
+                <a:spcPts val="0"/>
+              </a:spcBef>
+              <a:spcAft>
+                <a:spcPts val="0"/>
+              </a:spcAft>
+              <a:buSzPts val="2400"/>
+              <a:buNone/>
+            </a:pPr>
+            <a:r>
+              <a:rPr lang="en-US" sz="1800" dirty="0">
+                <a:latin typeface="Courier New" panose="02070309020205020404" pitchFamily="49" charset="0"/>
+                <a:cs typeface="Courier New" panose="02070309020205020404" pitchFamily="49" charset="0"/>
+              </a:rPr>
+              <a:t>    </a:t>
+            </a:r>
+            <a:r>
+              <a:rPr lang="en-US" sz="1800" b="1" dirty="0">
+                <a:latin typeface="Courier New" panose="02070309020205020404" pitchFamily="49" charset="0"/>
+                <a:cs typeface="Courier New" panose="02070309020205020404" pitchFamily="49" charset="0"/>
+              </a:rPr>
+              <a:t>embed-resources: true</a:t>
+            </a:r>
+          </a:p>
+          <a:p>
+            <a:pPr marL="0" indent="0">
+              <a:spcBef>
+                <a:spcPts val="0"/>
+              </a:spcBef>
+              <a:spcAft>
+                <a:spcPts val="0"/>
+              </a:spcAft>
+              <a:buSzPts val="2400"/>
+              <a:buNone/>
+            </a:pPr>
+            <a:r>
+              <a:rPr lang="en-US" sz="1800" dirty="0">
+                <a:latin typeface="Courier New" panose="02070309020205020404" pitchFamily="49" charset="0"/>
+                <a:cs typeface="Courier New" panose="02070309020205020404" pitchFamily="49" charset="0"/>
+              </a:rPr>
+              <a:t>---</a:t>
+            </a:r>
+          </a:p>
+        </p:txBody>
+      </p:sp>
+      <p:sp>
+        <p:nvSpPr>
+          <p:cNvPr id="13" name="Google Shape;175;p24">
+            <a:extLst>
+              <a:ext uri="{FF2B5EF4-FFF2-40B4-BE49-F238E27FC236}">
+                <a16:creationId xmlns:a16="http://schemas.microsoft.com/office/drawing/2014/main" id="{F763A344-B550-36F3-FBBB-73E064387AD0}"/>
+              </a:ext>
+            </a:extLst>
+          </p:cNvPr>
+          <p:cNvSpPr txBox="1">
+            <a:spLocks/>
+          </p:cNvSpPr>
+          <p:nvPr/>
+        </p:nvSpPr>
+        <p:spPr>
+          <a:xfrm>
+            <a:off x="1262449" y="1404005"/>
+            <a:ext cx="1508658" cy="472610"/>
+          </a:xfrm>
+          <a:prstGeom prst="rect">
+            <a:avLst/>
+          </a:prstGeom>
+          <a:noFill/>
+          <a:ln>
+            <a:noFill/>
+          </a:ln>
+        </p:spPr>
+        <p:txBody>
+          <a:bodyPr spcFirstLastPara="1" vert="horz" wrap="square" lIns="91425" tIns="45700" rIns="91425" bIns="45700" rtlCol="0" anchor="t" anchorCtr="0">
+            <a:noAutofit/>
+          </a:bodyPr>
+          <a:lstStyle>
+            <a:lvl1pPr marL="228594" indent="-228594" algn="l" defTabSz="914377" rtl="0" eaLnBrk="1" latinLnBrk="0" hangingPunct="1">
+              <a:lnSpc>
+                <a:spcPct val="110000"/>
+              </a:lnSpc>
+              <a:spcBef>
+                <a:spcPts val="1000"/>
+              </a:spcBef>
+              <a:spcAft>
+                <a:spcPts val="600"/>
+              </a:spcAft>
+              <a:buClrTx/>
+              <a:buFont typeface="Arial" panose="020B0604020202020204" pitchFamily="34" charset="0"/>
+              <a:buChar char="•"/>
+              <a:defRPr sz="2400" kern="1200">
+                <a:solidFill>
+                  <a:schemeClr val="tx1"/>
+                </a:solidFill>
+                <a:latin typeface="Arial" panose="020B0604020202020204" pitchFamily="34" charset="0"/>
+                <a:ea typeface="+mn-ea"/>
+                <a:cs typeface="Arial" panose="020B0604020202020204" pitchFamily="34" charset="0"/>
+              </a:defRPr>
+            </a:lvl1pPr>
+            <a:lvl2pPr marL="542912" indent="-228594" algn="l" defTabSz="914377" rtl="0" eaLnBrk="1" latinLnBrk="0" hangingPunct="1">
+              <a:lnSpc>
+                <a:spcPct val="110000"/>
+              </a:lnSpc>
+              <a:spcBef>
+                <a:spcPts val="500"/>
+              </a:spcBef>
+              <a:spcAft>
+                <a:spcPts val="600"/>
+              </a:spcAft>
+              <a:buClrTx/>
+              <a:buFont typeface="Arial" panose="020B0604020202020204" pitchFamily="34" charset="0"/>
+              <a:buChar char="•"/>
+              <a:defRPr sz="2000" kern="1200">
+                <a:solidFill>
+                  <a:schemeClr val="tx1"/>
+                </a:solidFill>
+                <a:latin typeface="Arial" panose="020B0604020202020204" pitchFamily="34" charset="0"/>
+                <a:ea typeface="+mn-ea"/>
+                <a:cs typeface="Arial" panose="020B0604020202020204" pitchFamily="34" charset="0"/>
+              </a:defRPr>
+            </a:lvl2pPr>
+            <a:lvl3pPr marL="895328" indent="-228594" algn="l" defTabSz="914377" rtl="0" eaLnBrk="1" latinLnBrk="0" hangingPunct="1">
+              <a:lnSpc>
+                <a:spcPct val="110000"/>
+              </a:lnSpc>
+              <a:spcBef>
+                <a:spcPts val="500"/>
+              </a:spcBef>
+              <a:spcAft>
+                <a:spcPts val="600"/>
+              </a:spcAft>
+              <a:buClrTx/>
+              <a:buFont typeface="Arial" panose="020B0604020202020204" pitchFamily="34" charset="0"/>
+              <a:buChar char="•"/>
+              <a:defRPr sz="1800" kern="1200">
+                <a:solidFill>
+                  <a:schemeClr val="tx1"/>
+                </a:solidFill>
+                <a:latin typeface="Arial" panose="020B0604020202020204" pitchFamily="34" charset="0"/>
+                <a:ea typeface="+mn-ea"/>
+                <a:cs typeface="Arial" panose="020B0604020202020204" pitchFamily="34" charset="0"/>
+              </a:defRPr>
+            </a:lvl3pPr>
+            <a:lvl4pPr marL="1257269" indent="-228594" algn="l" defTabSz="914377" rtl="0" eaLnBrk="1" latinLnBrk="0" hangingPunct="1">
+              <a:lnSpc>
+                <a:spcPct val="110000"/>
+              </a:lnSpc>
+              <a:spcBef>
+                <a:spcPts val="500"/>
+              </a:spcBef>
+              <a:spcAft>
+                <a:spcPts val="600"/>
+              </a:spcAft>
+              <a:buClrTx/>
+              <a:buFont typeface="Arial" panose="020B0604020202020204" pitchFamily="34" charset="0"/>
+              <a:buChar char="•"/>
+              <a:defRPr sz="1600" kern="1200">
+                <a:solidFill>
+                  <a:schemeClr val="tx1"/>
+                </a:solidFill>
+                <a:latin typeface="Arial" panose="020B0604020202020204" pitchFamily="34" charset="0"/>
+                <a:ea typeface="+mn-ea"/>
+                <a:cs typeface="Arial" panose="020B0604020202020204" pitchFamily="34" charset="0"/>
+              </a:defRPr>
+            </a:lvl4pPr>
+            <a:lvl5pPr marL="1619210" indent="-228594" algn="l" defTabSz="914377" rtl="0" eaLnBrk="1" latinLnBrk="0" hangingPunct="1">
+              <a:lnSpc>
+                <a:spcPct val="110000"/>
+              </a:lnSpc>
+              <a:spcBef>
+                <a:spcPts val="500"/>
+              </a:spcBef>
+              <a:spcAft>
+                <a:spcPts val="600"/>
+              </a:spcAft>
+              <a:buClrTx/>
+              <a:buFont typeface="Arial" panose="020B0604020202020204" pitchFamily="34" charset="0"/>
+              <a:buChar char="•"/>
+              <a:tabLst>
+                <a:tab pos="1619210" algn="l"/>
+              </a:tabLst>
+              <a:defRPr sz="1600" kern="1200">
+                <a:solidFill>
+                  <a:schemeClr val="tx1"/>
+                </a:solidFill>
+                <a:latin typeface="Arial" panose="020B0604020202020204" pitchFamily="34" charset="0"/>
+                <a:ea typeface="+mn-ea"/>
+                <a:cs typeface="Arial" panose="020B0604020202020204" pitchFamily="34" charset="0"/>
+              </a:defRPr>
+            </a:lvl5pPr>
+            <a:lvl6pPr marL="2514537" indent="-228594" algn="l" defTabSz="914377" rtl="0" eaLnBrk="1" latinLnBrk="0" hangingPunct="1">
+              <a:lnSpc>
+                <a:spcPct val="90000"/>
+              </a:lnSpc>
+              <a:spcBef>
+                <a:spcPts val="500"/>
+              </a:spcBef>
+              <a:buFont typeface="Arial" panose="020B0604020202020204" pitchFamily="34" charset="0"/>
+              <a:buChar char="•"/>
+              <a:defRPr sz="1800" kern="1200">
+                <a:solidFill>
+                  <a:schemeClr val="tx1"/>
+                </a:solidFill>
+                <a:latin typeface="+mn-lt"/>
+                <a:ea typeface="+mn-ea"/>
+                <a:cs typeface="+mn-cs"/>
+              </a:defRPr>
+            </a:lvl6pPr>
+            <a:lvl7pPr marL="2971726" indent="-228594" algn="l" defTabSz="914377" rtl="0" eaLnBrk="1" latinLnBrk="0" hangingPunct="1">
+              <a:lnSpc>
+                <a:spcPct val="90000"/>
+              </a:lnSpc>
+              <a:spcBef>
+                <a:spcPts val="500"/>
+              </a:spcBef>
+              <a:buFont typeface="Arial" panose="020B0604020202020204" pitchFamily="34" charset="0"/>
+              <a:buChar char="•"/>
+              <a:defRPr sz="1800" kern="1200">
+                <a:solidFill>
+                  <a:schemeClr val="tx1"/>
+                </a:solidFill>
+                <a:latin typeface="+mn-lt"/>
+                <a:ea typeface="+mn-ea"/>
+                <a:cs typeface="+mn-cs"/>
+              </a:defRPr>
+            </a:lvl7pPr>
+            <a:lvl8pPr marL="3428914" indent="-228594" algn="l" defTabSz="914377" rtl="0" eaLnBrk="1" latinLnBrk="0" hangingPunct="1">
+              <a:lnSpc>
+                <a:spcPct val="90000"/>
+              </a:lnSpc>
+              <a:spcBef>
+                <a:spcPts val="500"/>
+              </a:spcBef>
+              <a:buFont typeface="Arial" panose="020B0604020202020204" pitchFamily="34" charset="0"/>
+              <a:buChar char="•"/>
+              <a:defRPr sz="1800" kern="1200">
+                <a:solidFill>
+                  <a:schemeClr val="tx1"/>
+                </a:solidFill>
+                <a:latin typeface="+mn-lt"/>
+                <a:ea typeface="+mn-ea"/>
+                <a:cs typeface="+mn-cs"/>
+              </a:defRPr>
+            </a:lvl8pPr>
+            <a:lvl9pPr marL="3886103" indent="-228594" algn="l" defTabSz="914377" rtl="0" eaLnBrk="1" latinLnBrk="0" hangingPunct="1">
+              <a:lnSpc>
+                <a:spcPct val="90000"/>
+              </a:lnSpc>
+              <a:spcBef>
+                <a:spcPts val="500"/>
+              </a:spcBef>
+              <a:buFont typeface="Arial" panose="020B0604020202020204" pitchFamily="34" charset="0"/>
+              <a:buChar char="•"/>
+              <a:defRPr sz="1800" kern="1200">
+                <a:solidFill>
+                  <a:schemeClr val="tx1"/>
+                </a:solidFill>
+                <a:latin typeface="+mn-lt"/>
+                <a:ea typeface="+mn-ea"/>
+                <a:cs typeface="+mn-cs"/>
+              </a:defRPr>
+            </a:lvl9pPr>
+          </a:lstStyle>
+          <a:p>
+            <a:pPr marL="0" indent="0">
+              <a:spcBef>
+                <a:spcPts val="0"/>
+              </a:spcBef>
+              <a:spcAft>
+                <a:spcPts val="0"/>
+              </a:spcAft>
+              <a:buSzPts val="2400"/>
+              <a:buNone/>
+            </a:pPr>
+            <a:r>
+              <a:rPr lang="en-US" sz="2000" b="1" dirty="0">
+                <a:latin typeface="Courier New" panose="02070309020205020404" pitchFamily="49" charset="0"/>
+                <a:cs typeface="Courier New" panose="02070309020205020404" pitchFamily="49" charset="0"/>
+              </a:rPr>
+              <a:t>Quarto</a:t>
+            </a:r>
+          </a:p>
+        </p:txBody>
+      </p:sp>
+      <p:grpSp>
+        <p:nvGrpSpPr>
+          <p:cNvPr id="20" name="Group 19">
+            <a:extLst>
+              <a:ext uri="{FF2B5EF4-FFF2-40B4-BE49-F238E27FC236}">
+                <a16:creationId xmlns:a16="http://schemas.microsoft.com/office/drawing/2014/main" id="{A13FDEF4-7E06-37D3-4757-32F8BCF838C8}"/>
+              </a:ext>
+            </a:extLst>
+          </p:cNvPr>
+          <p:cNvGrpSpPr/>
+          <p:nvPr/>
+        </p:nvGrpSpPr>
+        <p:grpSpPr>
+          <a:xfrm>
+            <a:off x="5309470" y="2349573"/>
+            <a:ext cx="6501006" cy="707886"/>
+            <a:chOff x="5875255" y="3270423"/>
+            <a:chExt cx="4310147" cy="841815"/>
+          </a:xfrm>
+        </p:grpSpPr>
+        <p:sp>
+          <p:nvSpPr>
+            <p:cNvPr id="30" name="TextBox 29">
+              <a:extLst>
+                <a:ext uri="{FF2B5EF4-FFF2-40B4-BE49-F238E27FC236}">
+                  <a16:creationId xmlns:a16="http://schemas.microsoft.com/office/drawing/2014/main" id="{E69320D6-4432-FF99-1174-9B2824706CA5}"/>
+                </a:ext>
+              </a:extLst>
+            </p:cNvPr>
+            <p:cNvSpPr txBox="1"/>
+            <p:nvPr/>
+          </p:nvSpPr>
+          <p:spPr>
+            <a:xfrm>
+              <a:off x="6483625" y="3270423"/>
+              <a:ext cx="3701777" cy="841815"/>
+            </a:xfrm>
+            <a:prstGeom prst="rect">
+              <a:avLst/>
+            </a:prstGeom>
+            <a:noFill/>
+          </p:spPr>
+          <p:txBody>
+            <a:bodyPr wrap="square">
+              <a:spAutoFit/>
+            </a:bodyPr>
+            <a:lstStyle/>
+            <a:p>
+              <a:pPr>
+                <a:buSzPts val="2400"/>
+              </a:pPr>
+              <a:r>
+                <a:rPr lang="en-US" sz="2000" dirty="0">
+                  <a:latin typeface="Arial" panose="020B0604020202020204" pitchFamily="34" charset="0"/>
+                  <a:cs typeface="Arial" panose="020B0604020202020204" pitchFamily="34" charset="0"/>
+                </a:rPr>
+                <a:t>Images, themes, etc., are embedded, allowing you to share a </a:t>
+              </a:r>
+              <a:r>
+                <a:rPr lang="en-US" sz="2000" b="1" u="sng" dirty="0">
+                  <a:latin typeface="Arial" panose="020B0604020202020204" pitchFamily="34" charset="0"/>
+                  <a:cs typeface="Arial" panose="020B0604020202020204" pitchFamily="34" charset="0"/>
+                </a:rPr>
+                <a:t>single</a:t>
+              </a:r>
+              <a:r>
+                <a:rPr lang="en-US" sz="2000" dirty="0">
+                  <a:latin typeface="Arial" panose="020B0604020202020204" pitchFamily="34" charset="0"/>
+                  <a:cs typeface="Arial" panose="020B0604020202020204" pitchFamily="34" charset="0"/>
+                </a:rPr>
+                <a:t> file</a:t>
+              </a:r>
+            </a:p>
+          </p:txBody>
+        </p:sp>
+        <p:cxnSp>
+          <p:nvCxnSpPr>
+            <p:cNvPr id="31" name="Curved Connector 30">
+              <a:extLst>
+                <a:ext uri="{FF2B5EF4-FFF2-40B4-BE49-F238E27FC236}">
+                  <a16:creationId xmlns:a16="http://schemas.microsoft.com/office/drawing/2014/main" id="{B1333896-A4F5-D5B9-774B-8257D758597C}"/>
+                </a:ext>
+              </a:extLst>
+            </p:cNvPr>
+            <p:cNvCxnSpPr>
+              <a:cxnSpLocks/>
+              <a:endCxn id="30" idx="1"/>
+            </p:cNvCxnSpPr>
+            <p:nvPr/>
+          </p:nvCxnSpPr>
+          <p:spPr>
+            <a:xfrm flipV="1">
+              <a:off x="5875255" y="3691330"/>
+              <a:ext cx="608370" cy="227387"/>
+            </a:xfrm>
+            <a:prstGeom prst="curvedConnector3">
+              <a:avLst>
+                <a:gd name="adj1" fmla="val 50000"/>
+              </a:avLst>
+            </a:prstGeom>
+            <a:ln w="38100">
+              <a:solidFill>
+                <a:schemeClr val="accent5"/>
+              </a:solidFill>
+              <a:headEnd type="triangle"/>
+              <a:tailEnd type="none"/>
+            </a:ln>
+          </p:spPr>
+          <p:style>
+            <a:lnRef idx="1">
+              <a:schemeClr val="accent1"/>
+            </a:lnRef>
+            <a:fillRef idx="0">
+              <a:schemeClr val="accent1"/>
+            </a:fillRef>
+            <a:effectRef idx="0">
+              <a:schemeClr val="accent1"/>
+            </a:effectRef>
+            <a:fontRef idx="minor">
+              <a:schemeClr val="tx1"/>
+            </a:fontRef>
+          </p:style>
+        </p:cxnSp>
+      </p:grpSp>
+      <p:sp>
+        <p:nvSpPr>
+          <p:cNvPr id="42" name="TextBox 41">
+            <a:extLst>
+              <a:ext uri="{FF2B5EF4-FFF2-40B4-BE49-F238E27FC236}">
+                <a16:creationId xmlns:a16="http://schemas.microsoft.com/office/drawing/2014/main" id="{255FD5A1-FA5B-9C6D-0A2D-59ED6DC2F930}"/>
+              </a:ext>
+            </a:extLst>
+          </p:cNvPr>
+          <p:cNvSpPr txBox="1"/>
+          <p:nvPr/>
+        </p:nvSpPr>
+        <p:spPr>
+          <a:xfrm>
+            <a:off x="273077" y="938700"/>
+            <a:ext cx="5583400" cy="461665"/>
+          </a:xfrm>
+          <a:prstGeom prst="rect">
+            <a:avLst/>
+          </a:prstGeom>
+          <a:noFill/>
+        </p:spPr>
+        <p:txBody>
+          <a:bodyPr wrap="square">
+            <a:spAutoFit/>
+          </a:bodyPr>
+          <a:lstStyle/>
+          <a:p>
+            <a:pPr>
+              <a:buSzPts val="2400"/>
+            </a:pPr>
+            <a:r>
+              <a:rPr lang="en-US" sz="2400" b="1" dirty="0">
+                <a:latin typeface="Arial" panose="020B0604020202020204" pitchFamily="34" charset="0"/>
+                <a:cs typeface="Arial" panose="020B0604020202020204" pitchFamily="34" charset="0"/>
+              </a:rPr>
+              <a:t>Embedding resources</a:t>
+            </a:r>
+          </a:p>
+        </p:txBody>
+      </p:sp>
+      <p:sp>
+        <p:nvSpPr>
+          <p:cNvPr id="43" name="TextBox 42">
+            <a:extLst>
+              <a:ext uri="{FF2B5EF4-FFF2-40B4-BE49-F238E27FC236}">
+                <a16:creationId xmlns:a16="http://schemas.microsoft.com/office/drawing/2014/main" id="{4186FA18-C9DF-2C93-9DD2-546DE7FE5EEB}"/>
+              </a:ext>
+            </a:extLst>
+          </p:cNvPr>
+          <p:cNvSpPr txBox="1"/>
+          <p:nvPr/>
+        </p:nvSpPr>
+        <p:spPr>
+          <a:xfrm>
+            <a:off x="347113" y="3848207"/>
+            <a:ext cx="5583400" cy="461665"/>
+          </a:xfrm>
+          <a:prstGeom prst="rect">
+            <a:avLst/>
+          </a:prstGeom>
+          <a:noFill/>
+        </p:spPr>
+        <p:txBody>
+          <a:bodyPr wrap="square">
+            <a:spAutoFit/>
+          </a:bodyPr>
+          <a:lstStyle/>
+          <a:p>
+            <a:pPr>
+              <a:buSzPts val="2400"/>
+            </a:pPr>
+            <a:r>
+              <a:rPr lang="en-US" sz="2400" b="1" dirty="0">
+                <a:latin typeface="Arial" panose="020B0604020202020204" pitchFamily="34" charset="0"/>
+                <a:cs typeface="Arial" panose="020B0604020202020204" pitchFamily="34" charset="0"/>
+              </a:rPr>
+              <a:t>Sharing files</a:t>
+            </a:r>
+          </a:p>
+        </p:txBody>
+      </p:sp>
+      <p:sp>
+        <p:nvSpPr>
+          <p:cNvPr id="44" name="Google Shape;175;p24">
+            <a:extLst>
+              <a:ext uri="{FF2B5EF4-FFF2-40B4-BE49-F238E27FC236}">
+                <a16:creationId xmlns:a16="http://schemas.microsoft.com/office/drawing/2014/main" id="{57B4EE4E-07B8-28FA-82C4-7697EA7A5162}"/>
+              </a:ext>
+            </a:extLst>
+          </p:cNvPr>
+          <p:cNvSpPr txBox="1">
+            <a:spLocks/>
+          </p:cNvSpPr>
+          <p:nvPr/>
+        </p:nvSpPr>
+        <p:spPr>
+          <a:xfrm>
+            <a:off x="5856477" y="5495025"/>
+            <a:ext cx="4732785" cy="358849"/>
+          </a:xfrm>
+          <a:prstGeom prst="rect">
+            <a:avLst/>
+          </a:prstGeom>
+          <a:noFill/>
+          <a:ln>
+            <a:noFill/>
+          </a:ln>
+        </p:spPr>
+        <p:txBody>
+          <a:bodyPr spcFirstLastPara="1" vert="horz" wrap="square" lIns="91425" tIns="45700" rIns="91425" bIns="45700" rtlCol="0" anchor="t" anchorCtr="0">
+            <a:noAutofit/>
+          </a:bodyPr>
+          <a:lstStyle>
+            <a:lvl1pPr marL="228594" indent="-228594" algn="l" defTabSz="914377" rtl="0" eaLnBrk="1" latinLnBrk="0" hangingPunct="1">
+              <a:lnSpc>
+                <a:spcPct val="110000"/>
+              </a:lnSpc>
+              <a:spcBef>
+                <a:spcPts val="1000"/>
+              </a:spcBef>
+              <a:spcAft>
+                <a:spcPts val="600"/>
+              </a:spcAft>
+              <a:buClrTx/>
+              <a:buFont typeface="Arial" panose="020B0604020202020204" pitchFamily="34" charset="0"/>
+              <a:buChar char="•"/>
+              <a:defRPr sz="2400" kern="1200">
+                <a:solidFill>
+                  <a:schemeClr val="tx1"/>
+                </a:solidFill>
+                <a:latin typeface="Arial" panose="020B0604020202020204" pitchFamily="34" charset="0"/>
+                <a:ea typeface="+mn-ea"/>
+                <a:cs typeface="Arial" panose="020B0604020202020204" pitchFamily="34" charset="0"/>
+              </a:defRPr>
+            </a:lvl1pPr>
+            <a:lvl2pPr marL="542912" indent="-228594" algn="l" defTabSz="914377" rtl="0" eaLnBrk="1" latinLnBrk="0" hangingPunct="1">
+              <a:lnSpc>
+                <a:spcPct val="110000"/>
+              </a:lnSpc>
+              <a:spcBef>
+                <a:spcPts val="500"/>
+              </a:spcBef>
+              <a:spcAft>
+                <a:spcPts val="600"/>
+              </a:spcAft>
+              <a:buClrTx/>
+              <a:buFont typeface="Arial" panose="020B0604020202020204" pitchFamily="34" charset="0"/>
+              <a:buChar char="•"/>
+              <a:defRPr sz="2000" kern="1200">
+                <a:solidFill>
+                  <a:schemeClr val="tx1"/>
+                </a:solidFill>
+                <a:latin typeface="Arial" panose="020B0604020202020204" pitchFamily="34" charset="0"/>
+                <a:ea typeface="+mn-ea"/>
+                <a:cs typeface="Arial" panose="020B0604020202020204" pitchFamily="34" charset="0"/>
+              </a:defRPr>
+            </a:lvl2pPr>
+            <a:lvl3pPr marL="895328" indent="-228594" algn="l" defTabSz="914377" rtl="0" eaLnBrk="1" latinLnBrk="0" hangingPunct="1">
+              <a:lnSpc>
+                <a:spcPct val="110000"/>
+              </a:lnSpc>
+              <a:spcBef>
+                <a:spcPts val="500"/>
+              </a:spcBef>
+              <a:spcAft>
+                <a:spcPts val="600"/>
+              </a:spcAft>
+              <a:buClrTx/>
+              <a:buFont typeface="Arial" panose="020B0604020202020204" pitchFamily="34" charset="0"/>
+              <a:buChar char="•"/>
+              <a:defRPr sz="1800" kern="1200">
+                <a:solidFill>
+                  <a:schemeClr val="tx1"/>
+                </a:solidFill>
+                <a:latin typeface="Arial" panose="020B0604020202020204" pitchFamily="34" charset="0"/>
+                <a:ea typeface="+mn-ea"/>
+                <a:cs typeface="Arial" panose="020B0604020202020204" pitchFamily="34" charset="0"/>
+              </a:defRPr>
+            </a:lvl3pPr>
+            <a:lvl4pPr marL="1257269" indent="-228594" algn="l" defTabSz="914377" rtl="0" eaLnBrk="1" latinLnBrk="0" hangingPunct="1">
+              <a:lnSpc>
+                <a:spcPct val="110000"/>
+              </a:lnSpc>
+              <a:spcBef>
+                <a:spcPts val="500"/>
+              </a:spcBef>
+              <a:spcAft>
+                <a:spcPts val="600"/>
+              </a:spcAft>
+              <a:buClrTx/>
+              <a:buFont typeface="Arial" panose="020B0604020202020204" pitchFamily="34" charset="0"/>
+              <a:buChar char="•"/>
+              <a:defRPr sz="1600" kern="1200">
+                <a:solidFill>
+                  <a:schemeClr val="tx1"/>
+                </a:solidFill>
+                <a:latin typeface="Arial" panose="020B0604020202020204" pitchFamily="34" charset="0"/>
+                <a:ea typeface="+mn-ea"/>
+                <a:cs typeface="Arial" panose="020B0604020202020204" pitchFamily="34" charset="0"/>
+              </a:defRPr>
+            </a:lvl4pPr>
+            <a:lvl5pPr marL="1619210" indent="-228594" algn="l" defTabSz="914377" rtl="0" eaLnBrk="1" latinLnBrk="0" hangingPunct="1">
+              <a:lnSpc>
+                <a:spcPct val="110000"/>
+              </a:lnSpc>
+              <a:spcBef>
+                <a:spcPts val="500"/>
+              </a:spcBef>
+              <a:spcAft>
+                <a:spcPts val="600"/>
+              </a:spcAft>
+              <a:buClrTx/>
+              <a:buFont typeface="Arial" panose="020B0604020202020204" pitchFamily="34" charset="0"/>
+              <a:buChar char="•"/>
+              <a:tabLst>
+                <a:tab pos="1619210" algn="l"/>
+              </a:tabLst>
+              <a:defRPr sz="1600" kern="1200">
+                <a:solidFill>
+                  <a:schemeClr val="tx1"/>
+                </a:solidFill>
+                <a:latin typeface="Arial" panose="020B0604020202020204" pitchFamily="34" charset="0"/>
+                <a:ea typeface="+mn-ea"/>
+                <a:cs typeface="Arial" panose="020B0604020202020204" pitchFamily="34" charset="0"/>
+              </a:defRPr>
+            </a:lvl5pPr>
+            <a:lvl6pPr marL="2514537" indent="-228594" algn="l" defTabSz="914377" rtl="0" eaLnBrk="1" latinLnBrk="0" hangingPunct="1">
+              <a:lnSpc>
+                <a:spcPct val="90000"/>
+              </a:lnSpc>
+              <a:spcBef>
+                <a:spcPts val="500"/>
+              </a:spcBef>
+              <a:buFont typeface="Arial" panose="020B0604020202020204" pitchFamily="34" charset="0"/>
+              <a:buChar char="•"/>
+              <a:defRPr sz="1800" kern="1200">
+                <a:solidFill>
+                  <a:schemeClr val="tx1"/>
+                </a:solidFill>
+                <a:latin typeface="+mn-lt"/>
+                <a:ea typeface="+mn-ea"/>
+                <a:cs typeface="+mn-cs"/>
+              </a:defRPr>
+            </a:lvl6pPr>
+            <a:lvl7pPr marL="2971726" indent="-228594" algn="l" defTabSz="914377" rtl="0" eaLnBrk="1" latinLnBrk="0" hangingPunct="1">
+              <a:lnSpc>
+                <a:spcPct val="90000"/>
+              </a:lnSpc>
+              <a:spcBef>
+                <a:spcPts val="500"/>
+              </a:spcBef>
+              <a:buFont typeface="Arial" panose="020B0604020202020204" pitchFamily="34" charset="0"/>
+              <a:buChar char="•"/>
+              <a:defRPr sz="1800" kern="1200">
+                <a:solidFill>
+                  <a:schemeClr val="tx1"/>
+                </a:solidFill>
+                <a:latin typeface="+mn-lt"/>
+                <a:ea typeface="+mn-ea"/>
+                <a:cs typeface="+mn-cs"/>
+              </a:defRPr>
+            </a:lvl7pPr>
+            <a:lvl8pPr marL="3428914" indent="-228594" algn="l" defTabSz="914377" rtl="0" eaLnBrk="1" latinLnBrk="0" hangingPunct="1">
+              <a:lnSpc>
+                <a:spcPct val="90000"/>
+              </a:lnSpc>
+              <a:spcBef>
+                <a:spcPts val="500"/>
+              </a:spcBef>
+              <a:buFont typeface="Arial" panose="020B0604020202020204" pitchFamily="34" charset="0"/>
+              <a:buChar char="•"/>
+              <a:defRPr sz="1800" kern="1200">
+                <a:solidFill>
+                  <a:schemeClr val="tx1"/>
+                </a:solidFill>
+                <a:latin typeface="+mn-lt"/>
+                <a:ea typeface="+mn-ea"/>
+                <a:cs typeface="+mn-cs"/>
+              </a:defRPr>
+            </a:lvl8pPr>
+            <a:lvl9pPr marL="3886103" indent="-228594" algn="l" defTabSz="914377" rtl="0" eaLnBrk="1" latinLnBrk="0" hangingPunct="1">
+              <a:lnSpc>
+                <a:spcPct val="90000"/>
+              </a:lnSpc>
+              <a:spcBef>
+                <a:spcPts val="500"/>
+              </a:spcBef>
+              <a:buFont typeface="Arial" panose="020B0604020202020204" pitchFamily="34" charset="0"/>
+              <a:buChar char="•"/>
+              <a:defRPr sz="1800" kern="1200">
+                <a:solidFill>
+                  <a:schemeClr val="tx1"/>
+                </a:solidFill>
+                <a:latin typeface="+mn-lt"/>
+                <a:ea typeface="+mn-ea"/>
+                <a:cs typeface="+mn-cs"/>
+              </a:defRPr>
+            </a:lvl9pPr>
+          </a:lstStyle>
+          <a:p>
+            <a:pPr marL="0" indent="0">
+              <a:spcBef>
+                <a:spcPts val="0"/>
+              </a:spcBef>
+              <a:spcAft>
+                <a:spcPts val="0"/>
+              </a:spcAft>
+              <a:buSzPts val="2400"/>
+              <a:buNone/>
+            </a:pPr>
+            <a:r>
+              <a:rPr lang="en-US" sz="1400" b="1" dirty="0">
+                <a:latin typeface="Courier New" panose="02070309020205020404" pitchFamily="49" charset="0"/>
+                <a:cs typeface="Courier New" panose="02070309020205020404" pitchFamily="49" charset="0"/>
+              </a:rPr>
+              <a:t>http://localhost:7779/genome_report.html</a:t>
+            </a:r>
+          </a:p>
+        </p:txBody>
+      </p:sp>
+      <p:pic>
+        <p:nvPicPr>
+          <p:cNvPr id="50" name="Graphic 49" descr="Refresh with solid fill">
+            <a:extLst>
+              <a:ext uri="{FF2B5EF4-FFF2-40B4-BE49-F238E27FC236}">
+                <a16:creationId xmlns:a16="http://schemas.microsoft.com/office/drawing/2014/main" id="{3D8D2AF6-FEF0-4439-0598-22CCAFE66462}"/>
+              </a:ext>
+            </a:extLst>
+          </p:cNvPr>
+          <p:cNvPicPr>
+            <a:picLocks noChangeAspect="1"/>
+          </p:cNvPicPr>
+          <p:nvPr/>
+        </p:nvPicPr>
+        <p:blipFill>
+          <a:blip r:embed="rId3">
+            <a:extLst>
+              <a:ext uri="{96DAC541-7B7A-43D3-8B79-37D633B846F1}">
+                <asvg:svgBlip xmlns:asvg="http://schemas.microsoft.com/office/drawing/2016/SVG/main" r:embed="rId4"/>
+              </a:ext>
+            </a:extLst>
+          </a:blip>
+          <a:stretch>
+            <a:fillRect/>
+          </a:stretch>
+        </p:blipFill>
+        <p:spPr>
+          <a:xfrm>
+            <a:off x="10818890" y="5472577"/>
+            <a:ext cx="358850" cy="358850"/>
+          </a:xfrm>
+          <a:prstGeom prst="rect">
+            <a:avLst/>
+          </a:prstGeom>
+        </p:spPr>
+      </p:pic>
+      <p:pic>
+        <p:nvPicPr>
+          <p:cNvPr id="52" name="Graphic 51" descr="Document with solid fill">
+            <a:extLst>
+              <a:ext uri="{FF2B5EF4-FFF2-40B4-BE49-F238E27FC236}">
+                <a16:creationId xmlns:a16="http://schemas.microsoft.com/office/drawing/2014/main" id="{42DFB4FB-E863-3411-2673-5A4A5FEC8D2D}"/>
+              </a:ext>
+            </a:extLst>
+          </p:cNvPr>
+          <p:cNvPicPr>
+            <a:picLocks noChangeAspect="1"/>
+          </p:cNvPicPr>
+          <p:nvPr/>
+        </p:nvPicPr>
+        <p:blipFill>
+          <a:blip r:embed="rId5">
+            <a:extLst>
+              <a:ext uri="{96DAC541-7B7A-43D3-8B79-37D633B846F1}">
+                <asvg:svgBlip xmlns:asvg="http://schemas.microsoft.com/office/drawing/2016/SVG/main" r:embed="rId6"/>
+              </a:ext>
+            </a:extLst>
+          </a:blip>
+          <a:stretch>
+            <a:fillRect/>
+          </a:stretch>
+        </p:blipFill>
+        <p:spPr>
+          <a:xfrm>
+            <a:off x="1955286" y="4576483"/>
+            <a:ext cx="1631642" cy="1631642"/>
+          </a:xfrm>
+          <a:prstGeom prst="rect">
+            <a:avLst/>
+          </a:prstGeom>
+        </p:spPr>
+      </p:pic>
+      <p:sp>
+        <p:nvSpPr>
+          <p:cNvPr id="54" name="TextBox 53">
+            <a:extLst>
+              <a:ext uri="{FF2B5EF4-FFF2-40B4-BE49-F238E27FC236}">
+                <a16:creationId xmlns:a16="http://schemas.microsoft.com/office/drawing/2014/main" id="{2F5B1AC8-61A3-0991-B240-154852C33DB4}"/>
+              </a:ext>
+            </a:extLst>
+          </p:cNvPr>
+          <p:cNvSpPr txBox="1"/>
+          <p:nvPr/>
+        </p:nvSpPr>
+        <p:spPr>
+          <a:xfrm>
+            <a:off x="1403584" y="6127852"/>
+            <a:ext cx="2794000" cy="369332"/>
+          </a:xfrm>
+          <a:prstGeom prst="rect">
+            <a:avLst/>
+          </a:prstGeom>
+          <a:noFill/>
+        </p:spPr>
+        <p:txBody>
+          <a:bodyPr wrap="square">
+            <a:spAutoFit/>
+          </a:bodyPr>
+          <a:lstStyle/>
+          <a:p>
+            <a:pPr algn="ctr"/>
+            <a:r>
+              <a:rPr lang="en-US" sz="1800" b="1" dirty="0" err="1">
+                <a:latin typeface="Courier New" panose="02070309020205020404" pitchFamily="49" charset="0"/>
+                <a:cs typeface="Courier New" panose="02070309020205020404" pitchFamily="49" charset="0"/>
+              </a:rPr>
+              <a:t>genome_report.html</a:t>
+            </a:r>
+            <a:endParaRPr lang="en-US" dirty="0"/>
+          </a:p>
+        </p:txBody>
+      </p:sp>
+      <p:grpSp>
+        <p:nvGrpSpPr>
+          <p:cNvPr id="55" name="Group 54">
+            <a:extLst>
+              <a:ext uri="{FF2B5EF4-FFF2-40B4-BE49-F238E27FC236}">
+                <a16:creationId xmlns:a16="http://schemas.microsoft.com/office/drawing/2014/main" id="{D72044AC-5F28-9AEE-6E57-A9C4ADCD444F}"/>
+              </a:ext>
+            </a:extLst>
+          </p:cNvPr>
+          <p:cNvGrpSpPr/>
+          <p:nvPr/>
+        </p:nvGrpSpPr>
+        <p:grpSpPr>
+          <a:xfrm>
+            <a:off x="3409320" y="4062489"/>
+            <a:ext cx="6323397" cy="729247"/>
+            <a:chOff x="5993009" y="3270423"/>
+            <a:chExt cx="4192393" cy="867217"/>
+          </a:xfrm>
+        </p:grpSpPr>
+        <p:sp>
+          <p:nvSpPr>
+            <p:cNvPr id="56" name="TextBox 55">
+              <a:extLst>
+                <a:ext uri="{FF2B5EF4-FFF2-40B4-BE49-F238E27FC236}">
+                  <a16:creationId xmlns:a16="http://schemas.microsoft.com/office/drawing/2014/main" id="{79A58521-590B-A918-7B3D-C5081302504E}"/>
+                </a:ext>
+              </a:extLst>
+            </p:cNvPr>
+            <p:cNvSpPr txBox="1"/>
+            <p:nvPr/>
+          </p:nvSpPr>
+          <p:spPr>
+            <a:xfrm>
+              <a:off x="6483625" y="3270423"/>
+              <a:ext cx="3701777" cy="475809"/>
+            </a:xfrm>
+            <a:prstGeom prst="rect">
+              <a:avLst/>
+            </a:prstGeom>
+            <a:noFill/>
+          </p:spPr>
+          <p:txBody>
+            <a:bodyPr wrap="square">
+              <a:spAutoFit/>
+            </a:bodyPr>
+            <a:lstStyle/>
+            <a:p>
+              <a:pPr>
+                <a:buSzPts val="2400"/>
+              </a:pPr>
+              <a:r>
+                <a:rPr lang="en-US" sz="2000" dirty="0">
+                  <a:latin typeface="Arial" panose="020B0604020202020204" pitchFamily="34" charset="0"/>
+                  <a:cs typeface="Arial" panose="020B0604020202020204" pitchFamily="34" charset="0"/>
+                </a:rPr>
+                <a:t>Share the HTML file, </a:t>
+              </a:r>
+              <a:r>
+                <a:rPr lang="en-US" sz="2000" b="1" u="sng" dirty="0">
+                  <a:latin typeface="Arial" panose="020B0604020202020204" pitchFamily="34" charset="0"/>
+                  <a:cs typeface="Arial" panose="020B0604020202020204" pitchFamily="34" charset="0"/>
+                </a:rPr>
+                <a:t>not</a:t>
+              </a:r>
+              <a:r>
+                <a:rPr lang="en-US" sz="2000" dirty="0">
+                  <a:latin typeface="Arial" panose="020B0604020202020204" pitchFamily="34" charset="0"/>
+                  <a:cs typeface="Arial" panose="020B0604020202020204" pitchFamily="34" charset="0"/>
+                </a:rPr>
+                <a:t> the local URL</a:t>
+              </a:r>
+            </a:p>
+          </p:txBody>
+        </p:sp>
+        <p:cxnSp>
+          <p:nvCxnSpPr>
+            <p:cNvPr id="57" name="Curved Connector 56">
+              <a:extLst>
+                <a:ext uri="{FF2B5EF4-FFF2-40B4-BE49-F238E27FC236}">
+                  <a16:creationId xmlns:a16="http://schemas.microsoft.com/office/drawing/2014/main" id="{DD37AF5E-89EE-D33F-1994-8547200E9EAA}"/>
+                </a:ext>
+              </a:extLst>
+            </p:cNvPr>
+            <p:cNvCxnSpPr>
+              <a:cxnSpLocks/>
+              <a:endCxn id="56" idx="1"/>
+            </p:cNvCxnSpPr>
+            <p:nvPr/>
+          </p:nvCxnSpPr>
+          <p:spPr>
+            <a:xfrm flipV="1">
+              <a:off x="5993009" y="3508327"/>
+              <a:ext cx="490616" cy="629313"/>
+            </a:xfrm>
+            <a:prstGeom prst="curvedConnector3">
+              <a:avLst>
+                <a:gd name="adj1" fmla="val 50000"/>
+              </a:avLst>
+            </a:prstGeom>
+            <a:ln w="38100">
+              <a:solidFill>
+                <a:schemeClr val="accent5"/>
+              </a:solidFill>
+              <a:headEnd type="triangle"/>
+              <a:tailEnd type="none"/>
+            </a:ln>
+          </p:spPr>
+          <p:style>
+            <a:lnRef idx="1">
+              <a:schemeClr val="accent1"/>
+            </a:lnRef>
+            <a:fillRef idx="0">
+              <a:schemeClr val="accent1"/>
+            </a:fillRef>
+            <a:effectRef idx="0">
+              <a:schemeClr val="accent1"/>
+            </a:effectRef>
+            <a:fontRef idx="minor">
+              <a:schemeClr val="tx1"/>
+            </a:fontRef>
+          </p:style>
+        </p:cxnSp>
+      </p:grpSp>
+      <p:cxnSp>
+        <p:nvCxnSpPr>
+          <p:cNvPr id="60" name="Curved Connector 59">
+            <a:extLst>
+              <a:ext uri="{FF2B5EF4-FFF2-40B4-BE49-F238E27FC236}">
+                <a16:creationId xmlns:a16="http://schemas.microsoft.com/office/drawing/2014/main" id="{62EC49A9-8671-5FC2-4908-12EB9A177163}"/>
+              </a:ext>
+            </a:extLst>
+          </p:cNvPr>
+          <p:cNvCxnSpPr>
+            <a:cxnSpLocks/>
+          </p:cNvCxnSpPr>
+          <p:nvPr/>
+        </p:nvCxnSpPr>
+        <p:spPr>
+          <a:xfrm rot="16200000" flipV="1">
+            <a:off x="6721046" y="4564040"/>
+            <a:ext cx="473389" cy="270507"/>
+          </a:xfrm>
+          <a:prstGeom prst="curvedConnector3">
+            <a:avLst>
+              <a:gd name="adj1" fmla="val 50000"/>
+            </a:avLst>
+          </a:prstGeom>
+          <a:ln w="38100">
+            <a:solidFill>
+              <a:schemeClr val="accent2"/>
+            </a:solidFill>
+            <a:headEnd type="triangle"/>
+            <a:tailEnd type="none"/>
+          </a:ln>
+        </p:spPr>
+        <p:style>
+          <a:lnRef idx="1">
+            <a:schemeClr val="accent1"/>
+          </a:lnRef>
+          <a:fillRef idx="0">
+            <a:schemeClr val="accent1"/>
+          </a:fillRef>
+          <a:effectRef idx="0">
+            <a:schemeClr val="accent1"/>
+          </a:effectRef>
+          <a:fontRef idx="minor">
+            <a:schemeClr val="tx1"/>
+          </a:fontRef>
+        </p:style>
+      </p:cxnSp>
+    </p:spTree>
+    <p:extLst>
+      <p:ext uri="{BB962C8B-B14F-4D97-AF65-F5344CB8AC3E}">
+        <p14:creationId xmlns:p14="http://schemas.microsoft.com/office/powerpoint/2010/main" val="304825779"/>
+      </p:ext>
+    </p:extLst>
+  </p:cSld>
+  <p:clrMapOvr>
+    <a:masterClrMapping/>
+  </p:clrMapOvr>
+</p:sld>
+</file>
+
+<file path=ppt/slides/slide23.xml><?xml version="1.0" encoding="utf-8"?>
 <p:sld xmlns:a="http://schemas.openxmlformats.org/drawingml/2006/main" xmlns:r="http://schemas.openxmlformats.org/officeDocument/2006/relationships" xmlns:p="http://schemas.openxmlformats.org/presentationml/2006/main">
   <p:cSld>
     <p:spTree>
@@ -29475,7 +33125,7 @@
 </p:sld>
 </file>
 
-<file path=ppt/slides/slide22.xml><?xml version="1.0" encoding="utf-8"?>
+<file path=ppt/slides/slide24.xml><?xml version="1.0" encoding="utf-8"?>
 <p:sld xmlns:a="http://schemas.openxmlformats.org/drawingml/2006/main" xmlns:r="http://schemas.openxmlformats.org/officeDocument/2006/relationships" xmlns:p="http://schemas.openxmlformats.org/presentationml/2006/main">
   <p:cSld>
     <p:spTree>
@@ -31341,7 +34991,7 @@
           <a:p>
             <a:r>
               <a:rPr lang="en-US" dirty="0"/>
-              <a:t>Quarto Overviews</a:t>
+              <a:t>Quarto Overview</a:t>
             </a:r>
             <a:endParaRPr lang="en-US" dirty="0">
               <a:latin typeface="Courier New" panose="02070309020205020404" pitchFamily="49" charset="0"/>
@@ -39610,24 +43260,6 @@
 </file>
 
 <file path=customXml/item1.xml><?xml version="1.0" encoding="utf-8"?>
-<p:properties xmlns:p="http://schemas.microsoft.com/office/2006/metadata/properties" xmlns:xsi="http://www.w3.org/2001/XMLSchema-instance" xmlns:pc="http://schemas.microsoft.com/office/infopath/2007/PartnerControls">
-  <documentManagement>
-    <TaxCatchAll xmlns="36a2e673-aec1-4a31-bb25-5bf0d2fd598e" xsi:nil="true"/>
-    <SharedWithUsers xmlns="041e83a1-a141-481d-9569-60aed768ca01">
-      <UserInfo>
-        <DisplayName>Marketing and Communications Visitors</DisplayName>
-        <AccountId>5</AccountId>
-        <AccountType/>
-      </UserInfo>
-    </SharedWithUsers>
-    <lcf76f155ced4ddcb4097134ff3c332f xmlns="ff701802-113d-4d37-b72f-6ed4094120d6">
-      <Terms xmlns="http://schemas.microsoft.com/office/infopath/2007/PartnerControls"/>
-    </lcf76f155ced4ddcb4097134ff3c332f>
-  </documentManagement>
-</p:properties>
-</file>
-
-<file path=customXml/item2.xml><?xml version="1.0" encoding="utf-8"?>
 <ct:contentTypeSchema xmlns:ct="http://schemas.microsoft.com/office/2006/metadata/contentType" xmlns:ma="http://schemas.microsoft.com/office/2006/metadata/properties/metaAttributes" ct:_="" ma:_="" ma:contentTypeName="Document" ma:contentTypeID="0x0101001F9AC63AE4060A4EB0841E49751518A1" ma:contentTypeVersion="15" ma:contentTypeDescription="Create a new document." ma:contentTypeScope="" ma:versionID="215a7979ea70076864538727c09f6251">
   <xsd:schema xmlns:xsd="http://www.w3.org/2001/XMLSchema" xmlns:xs="http://www.w3.org/2001/XMLSchema" xmlns:p="http://schemas.microsoft.com/office/2006/metadata/properties" xmlns:ns2="ff701802-113d-4d37-b72f-6ed4094120d6" xmlns:ns3="041e83a1-a141-481d-9569-60aed768ca01" xmlns:ns4="36a2e673-aec1-4a31-bb25-5bf0d2fd598e" targetNamespace="http://schemas.microsoft.com/office/2006/metadata/properties" ma:root="true" ma:fieldsID="933f66ca9c60f05373724a7532c7a0a7" ns2:_="" ns3:_="" ns4:_="">
     <xsd:import namespace="ff701802-113d-4d37-b72f-6ed4094120d6"/>
@@ -39867,6 +43499,24 @@
 </ct:contentTypeSchema>
 </file>
 
+<file path=customXml/item2.xml><?xml version="1.0" encoding="utf-8"?>
+<p:properties xmlns:p="http://schemas.microsoft.com/office/2006/metadata/properties" xmlns:xsi="http://www.w3.org/2001/XMLSchema-instance" xmlns:pc="http://schemas.microsoft.com/office/infopath/2007/PartnerControls">
+  <documentManagement>
+    <TaxCatchAll xmlns="36a2e673-aec1-4a31-bb25-5bf0d2fd598e" xsi:nil="true"/>
+    <SharedWithUsers xmlns="041e83a1-a141-481d-9569-60aed768ca01">
+      <UserInfo>
+        <DisplayName>Marketing and Communications Visitors</DisplayName>
+        <AccountId>5</AccountId>
+        <AccountType/>
+      </UserInfo>
+    </SharedWithUsers>
+    <lcf76f155ced4ddcb4097134ff3c332f xmlns="ff701802-113d-4d37-b72f-6ed4094120d6">
+      <Terms xmlns="http://schemas.microsoft.com/office/infopath/2007/PartnerControls"/>
+    </lcf76f155ced4ddcb4097134ff3c332f>
+  </documentManagement>
+</p:properties>
+</file>
+
 <file path=customXml/item3.xml><?xml version="1.0" encoding="utf-8"?>
 <?mso-contentType ?>
 <FormTemplates xmlns="http://schemas.microsoft.com/sharepoint/v3/contenttype/forms">
@@ -39877,24 +43527,6 @@
 </file>
 
 <file path=customXml/itemProps1.xml><?xml version="1.0" encoding="utf-8"?>
-<ds:datastoreItem xmlns:ds="http://schemas.openxmlformats.org/officeDocument/2006/customXml" ds:itemID="{F906C323-2260-4F5C-A4E4-76E86AEA9B57}">
-  <ds:schemaRefs>
-    <ds:schemaRef ds:uri="http://schemas.microsoft.com/office/2006/documentManagement/types"/>
-    <ds:schemaRef ds:uri="http://purl.org/dc/dcmitype/"/>
-    <ds:schemaRef ds:uri="http://purl.org/dc/elements/1.1/"/>
-    <ds:schemaRef ds:uri="http://www.w3.org/XML/1998/namespace"/>
-    <ds:schemaRef ds:uri="http://schemas.openxmlformats.org/package/2006/metadata/core-properties"/>
-    <ds:schemaRef ds:uri="http://schemas.microsoft.com/office/infopath/2007/PartnerControls"/>
-    <ds:schemaRef ds:uri="http://schemas.microsoft.com/office/2006/metadata/properties"/>
-    <ds:schemaRef ds:uri="36a2e673-aec1-4a31-bb25-5bf0d2fd598e"/>
-    <ds:schemaRef ds:uri="041e83a1-a141-481d-9569-60aed768ca01"/>
-    <ds:schemaRef ds:uri="ff701802-113d-4d37-b72f-6ed4094120d6"/>
-    <ds:schemaRef ds:uri="http://purl.org/dc/terms/"/>
-  </ds:schemaRefs>
-</ds:datastoreItem>
-</file>
-
-<file path=customXml/itemProps2.xml><?xml version="1.0" encoding="utf-8"?>
 <ds:datastoreItem xmlns:ds="http://schemas.openxmlformats.org/officeDocument/2006/customXml" ds:itemID="{D8CBDC32-B55C-4118-8893-B5C4EA9F3DFE}">
   <ds:schemaRefs>
     <ds:schemaRef ds:uri="http://schemas.microsoft.com/office/2006/metadata/contentType"/>
@@ -39914,6 +43546,24 @@
 </ds:datastoreItem>
 </file>
 
+<file path=customXml/itemProps2.xml><?xml version="1.0" encoding="utf-8"?>
+<ds:datastoreItem xmlns:ds="http://schemas.openxmlformats.org/officeDocument/2006/customXml" ds:itemID="{F906C323-2260-4F5C-A4E4-76E86AEA9B57}">
+  <ds:schemaRefs>
+    <ds:schemaRef ds:uri="http://schemas.microsoft.com/office/2006/documentManagement/types"/>
+    <ds:schemaRef ds:uri="http://purl.org/dc/dcmitype/"/>
+    <ds:schemaRef ds:uri="http://purl.org/dc/elements/1.1/"/>
+    <ds:schemaRef ds:uri="http://www.w3.org/XML/1998/namespace"/>
+    <ds:schemaRef ds:uri="http://schemas.openxmlformats.org/package/2006/metadata/core-properties"/>
+    <ds:schemaRef ds:uri="http://schemas.microsoft.com/office/infopath/2007/PartnerControls"/>
+    <ds:schemaRef ds:uri="http://schemas.microsoft.com/office/2006/metadata/properties"/>
+    <ds:schemaRef ds:uri="36a2e673-aec1-4a31-bb25-5bf0d2fd598e"/>
+    <ds:schemaRef ds:uri="041e83a1-a141-481d-9569-60aed768ca01"/>
+    <ds:schemaRef ds:uri="ff701802-113d-4d37-b72f-6ed4094120d6"/>
+    <ds:schemaRef ds:uri="http://purl.org/dc/terms/"/>
+  </ds:schemaRefs>
+</ds:datastoreItem>
+</file>
+
 <file path=customXml/itemProps3.xml><?xml version="1.0" encoding="utf-8"?>
 <ds:datastoreItem xmlns:ds="http://schemas.openxmlformats.org/officeDocument/2006/customXml" ds:itemID="{23FE95EB-1D52-410E-A524-0B047EC84A3E}">
   <ds:schemaRefs>

</xml_diff>